<commit_message>
Rewrite deck copy: English technical terms, less essay-like tone
Per feedback: Greek CS/ECE speakers use the English terms, not calques like
κοκκομέτρηση / εύρος ζώνης / μετανάστευση σελίδων. Switched jargon to English
(granularity, bandwidth, latency, page migration, tiering, promotion/demotion,
hot pages, workloads, cache line, etc.) while keeping Greek grammar and
connective text. Also loosened the prose to read like a student wrote it —
shorter sentences, fewer balanced em-dash constructions.

All 14 slides re-rendered and verified.

Co-Authored-By: Claude Opus 4.8 <noreply@anthropic.com>
</commit_message>
<xml_diff>
--- a/docs/memory-tiering-cxl-gr.pptx
+++ b/docs/memory-tiering-cxl-gr.pptx
@@ -277,7 +277,7 @@
               <c:strCache>
                 <c:ptCount val="1"/>
                 <c:pt idx="0">
-                  <c:v>Ομοιόμορφη (GUPS)</c:v>
+                  <c:v>Uniform (GUPS)</c:v>
                 </c:pt>
               </c:strCache>
             </c:strRef>
@@ -463,7 +463,7 @@
                     </a:solidFill>
                     <a:latin typeface="Times New Roman"/>
                   </a:rPr>
-                  <a:t>k θερμότερες γραμμές 64 B (από 64)</a:t>
+                  <a:t>k πιο hot 64 B lines (από 64)</a:t>
                 </a:r>
               </a:p>
             </c:rich>
@@ -546,7 +546,7 @@
                     </a:solidFill>
                     <a:latin typeface="Times New Roman"/>
                   </a:rPr>
-                  <a:t>αθροιστικό %</a:t>
+                  <a:t>cumulative %</a:t>
                 </a:r>
               </a:p>
             </c:rich>
@@ -1026,7 +1026,7 @@
           <a:p>
             <a:r>
               <a:rPr lang="en-US" dirty="0"/>
-              <a:t>Στόχος: δείχνω ότι κατάλαβα το πρόβλημα και ότι έχω αξιόπιστο πλάνο. Δεν έχω ακόμα αποτελέσματα — και το λέω ανοιχτά.</a:t>
+              <a:t>Στόχος: δείχνω ότι κατάλαβα το πρόβλημα και ότι έχω αξιόπιστο πλάνο. Δεν έχω ακόμα αποτελέσματα, και το λέω ανοιχτά.</a:t>
             </a:r>
             <a:endParaRPr lang="en-US" dirty="0"/>
           </a:p>
@@ -1114,7 +1114,7 @@
           <a:p>
             <a:r>
               <a:rPr lang="en-US" dirty="0"/>
-              <a:t>Ανοιχτό θέμα: χρειάζομαι πρόσβαση στο αποθετήριο του CXLRAMSim — δεν βρήκα δημόσιο repo.</a:t>
+              <a:t>Ανοιχτό θέμα: χρειάζομαι πρόσβαση στο repo του CXLRAMSim — δεν βρήκα δημόσιο.</a:t>
             </a:r>
             <a:endParaRPr lang="en-US" dirty="0"/>
           </a:p>
@@ -1202,7 +1202,7 @@
           <a:p>
             <a:r>
               <a:rPr lang="en-US" dirty="0"/>
-              <a:t>Πάντα αναφέρω και τα δύο φράγματα δίπλα σε κάθε σχήμα — αλλιώς το νούμερο δεν ερμηνεύεται.</a:t>
+              <a:t>Πάντα αναφέρω και τα δύο bounds δίπλα σε κάθε case — αλλιώς το νούμερο δεν ερμηνεύεται.</a:t>
             </a:r>
             <a:endParaRPr lang="en-US" dirty="0"/>
           </a:p>
@@ -1290,7 +1290,7 @@
           <a:p>
             <a:r>
               <a:rPr lang="en-US" dirty="0"/>
-              <a:t>Σκίτσο, όχι δεδομένα — και το δηλώνω. Ο Zipf δείχνει ακραία συγκέντρωση· το GUPS είναι αρνητικός έλεγχος.</a:t>
+              <a:t>Σκίτσο, όχι δεδομένα — και το δηλώνω. Ο Zipf δείχνει ακραία συγκέντρωση· το GUPS είναι το negative control.</a:t>
             </a:r>
             <a:endParaRPr lang="en-US" dirty="0"/>
           </a:p>
@@ -1378,7 +1378,7 @@
           <a:p>
             <a:r>
               <a:rPr lang="en-US" dirty="0"/>
-              <a:t>Δηλώνω ξεκάθαρα τι είναι βασικό και τι stretch goal.</a:t>
+              <a:t>Δηλώνω ξεκάθαρα τι είναι core και τι stretch goal.</a:t>
             </a:r>
             <a:endParaRPr lang="en-US" dirty="0"/>
           </a:p>
@@ -1466,7 +1466,7 @@
           <a:p>
             <a:r>
               <a:rPr lang="en-US" dirty="0"/>
-              <a:t>Έτοιμη απάντηση για «γιατί όχι απευθείας cache lines»: δεν υπάρχει PTE για γραμμή → έμμεση αναφορά σε υλικό → Flat Memory Mode → κοστίζει αστοχίες σύγκρουσης και χωρητικότητα → αυτό ακριβώς λύνει το Memstrata.</a:t>
+              <a:t>Έτοιμη απάντηση για «γιατί όχι κατευθείαν cache lines»: δεν υπάρχει PTE για line → hardware indirection → Flat Memory Mode → κοστίζει conflict misses και capacity → αυτό ακριβώς λύνει το Memstrata.</a:t>
             </a:r>
             <a:endParaRPr lang="en-US" dirty="0"/>
           </a:p>
@@ -1554,7 +1554,7 @@
           <a:p>
             <a:r>
               <a:rPr lang="en-US" dirty="0"/>
-              <a:t>Ένας αριθμός να μείνει: ~25% stranded DRAM. Το οικονομικό κίνητρο όλου του πεδίου.</a:t>
+              <a:t>Ένα νούμερο να μείνει: ~25% stranded DRAM. Το οικονομικό κίνητρο όλου του πεδίου.</a:t>
             </a:r>
             <a:endParaRPr lang="en-US" dirty="0"/>
           </a:p>
@@ -1642,7 +1642,7 @@
           <a:p>
             <a:r>
               <a:rPr lang="en-US" dirty="0"/>
-              <a:t>Το σημείο: η DRAM στην κάρτα είναι κανονική DDR5. Η διασύνδεση είναι ο φόρος — γι' αυτό υπάρχει tiering.</a:t>
+              <a:t>Το σημείο: η DRAM στην κάρτα είναι κανονική DDR5. Το interconnect είναι ο φόρος — γι' αυτό υπάρχει tiering.</a:t>
             </a:r>
             <a:endParaRPr lang="en-US" dirty="0"/>
           </a:p>
@@ -1730,7 +1730,7 @@
           <a:p>
             <a:r>
               <a:rPr lang="en-US" dirty="0"/>
-              <a:t>Γιατί δύσκολη η προαγωγή: απαιτεί να ξέρεις ότι μια σελίδα είναι θερμή ΤΩΡΑ.</a:t>
+              <a:t>Γιατί δύσκολο το promotion: πρέπει να ξέρεις ότι ένα page είναι hot ΤΩΡΑ.</a:t>
             </a:r>
             <a:endParaRPr lang="en-US" dirty="0"/>
           </a:p>
@@ -1818,7 +1818,7 @@
           <a:p>
             <a:r>
               <a:rPr lang="en-US" dirty="0"/>
-              <a:t>Κοινός παρονομαστής: ακρίβεια × επικαιρότητα × overhead — διάλεξε δύο.</a:t>
+              <a:t>Κοινός παρονομαστής: accuracy × timeliness × overhead — διάλεξε δύο.</a:t>
             </a:r>
             <a:endParaRPr lang="en-US" dirty="0"/>
           </a:p>
@@ -1906,7 +1906,7 @@
           <a:p>
             <a:r>
               <a:rPr lang="en-US" dirty="0"/>
-              <a:t>Εδώ θα με ρωτήσουν. Απάντηση: κοκκομέτρηση profiling ≠ κοκκομέτρηση migration. Το M5 profiling στα 64 B, migration στα 4 KB.</a:t>
+              <a:t>Εδώ θα με ρωτήσουν. Απάντηση: profiling granularity ≠ migration granularity. Το M5 profiling στα 64 B, migration στα 4 KB.</a:t>
             </a:r>
             <a:endParaRPr lang="en-US" dirty="0"/>
           </a:p>
@@ -1994,7 +1994,7 @@
           <a:p>
             <a:r>
               <a:rPr lang="en-US" dirty="0"/>
-              <a:t>Τάξη μεγέθους: μικροδευτερόλεπτα έναντι νανοδευτερολέπτων. Χιλιαπλάσιο κόστος.</a:t>
+              <a:t>Τάξη μεγέθους: μsec έναντι ns. Χιλιαπλάσιο κόστος.</a:t>
             </a:r>
             <a:endParaRPr lang="en-US" dirty="0"/>
           </a:p>
@@ -2170,7 +2170,7 @@
           <a:p>
             <a:r>
               <a:rPr lang="en-US" dirty="0"/>
-              <a:t>Αυτή η διαφάνεια ξεχωρίζει το «διάβασα μια εργασία» από το «κατάλαβα το πρόβλημα».</a:t>
+              <a:t>Αυτή η διαφάνεια ξεχωρίζει το «διάβασα ένα paper» από το «κατάλαβα το πρόβλημα».</a:t>
             </a:r>
             <a:endParaRPr lang="en-US" dirty="0"/>
           </a:p>
@@ -2657,7 +2657,7 @@
                 <a:ea typeface="Times New Roman" pitchFamily="34" charset="-122"/>
                 <a:cs typeface="Times New Roman" pitchFamily="34" charset="-120"/>
               </a:rPr>
-              <a:t>Προσομοίωση τεχνικών ιεραρχικής διαχείρισης μνήμης με υποστήριξη υλικού, στον προσομοιωτή CXLRAMSim</a:t>
+              <a:t>Προσομοίωση τεχνικών memory tiering με υποστήριξη hardware, πάνω στον προσομοιωτή CXLRAMSim</a:t>
             </a:r>
             <a:endParaRPr lang="en-US" sz="1800" dirty="0"/>
           </a:p>
@@ -2758,7 +2758,7 @@
                 <a:ea typeface="Times New Roman" pitchFamily="34" charset="-122"/>
                 <a:cs typeface="Times New Roman" pitchFamily="34" charset="-120"/>
               </a:rPr>
-              <a:t>Οι μνήμες CXL προσφέρουν φθηνή χωρητικότητα πάνω από τον δίαυλο PCIe, με το τίμημα ~2–3× μεγαλύτερης καθυστέρησης· σχηματίζουν έτσι ένα σύστημα μνήμης δύο βαθμίδων. Η παρούσα εργασία αναπαράγει, στον προσομοιωτή CXLRAMSim, γιατί η μετανάστευση σελίδων 4 KB από το λειτουργικό σύστημα αποτυγχάνει να γεφυρώσει το χάσμα επίδοσης προς την τοπική DRAM, και εξετάζει λύσεις με υποστήριξη υλικού (M5, NeoMem, Memstrata) που κάνουν profiling μέσα στη συσκευή CXL.</a:t>
+              <a:t>Οι μνήμες CXL δίνουν φθηνή capacity πάνω από το PCIe, αλλά με ~2–3× μεγαλύτερο latency. Έτσι προκύπτει ένα σύστημα μνήμης δύο επιπέδων (tiering). Η εργασία δείχνει, μέσα στον CXLRAMSim, γιατί το page migration των 4 KB από το OS δεν φτάνει για να καλύψει το χάσμα απόδοσης με την τοπική DRAM, και εξετάζει λύσεις σε hardware (M5, NeoMem, Memstrata) που κάνουν profiling μέσα στη συσκευή CXL.</a:t>
             </a:r>
             <a:endParaRPr lang="en-US" sz="1450" dirty="0"/>
           </a:p>
@@ -2797,7 +2797,7 @@
                 <a:ea typeface="Times New Roman" pitchFamily="34" charset="-122"/>
                 <a:cs typeface="Times New Roman" pitchFamily="34" charset="-120"/>
               </a:rPr>
-              <a:t>Λέξεις-κλειδιά:  </a:t>
+              <a:t>Keywords:  </a:t>
             </a:r>
             <a:pPr indent="0" marL="0">
               <a:buNone/>
@@ -2811,7 +2811,7 @@
                 <a:ea typeface="Times New Roman" pitchFamily="34" charset="-122"/>
                 <a:cs typeface="Times New Roman" pitchFamily="34" charset="-120"/>
               </a:rPr>
-              <a:t>CXL · memory tiering · μετανάστευση σελίδων · profiling υλικού · κοκκομέτρηση</a:t>
+              <a:t>CXL · memory tiering · page migration · hardware profiling · granularity</a:t>
             </a:r>
             <a:endParaRPr lang="en-US" sz="1300" dirty="0"/>
           </a:p>
@@ -3187,7 +3187,7 @@
                 <a:ea typeface="Times New Roman" pitchFamily="34" charset="-122"/>
                 <a:cs typeface="Times New Roman" pitchFamily="34" charset="-120"/>
               </a:rPr>
-              <a:t>Ο CXLRAMSim είναι προσομοιωτής πλήρους συστήματος πάνω στο gem5 v25, με εκκίνηση Linux 6.14. Μοντελοποιεί τη συσκευή CXL στη σωστή θέση πάνω στον δίαυλο I/O, επιτρέποντας αναλλοίωτο πυρήνα, οδηγούς και στοίβα λογισμικού.</a:t>
+              <a:t>Ο CXLRAMSim είναι full-system προσομοιωτής πάνω στο gem5 v25, που μπουτάρει Linux 6.14. Βάζει τη συσκευή CXL στη σωστή θέση πάνω στο I/O bus, οπότε ο kernel, οι drivers και το software stack μένουν αναλλοίωτα.</a:t>
             </a:r>
             <a:endParaRPr lang="en-US" sz="1600" dirty="0"/>
           </a:p>
@@ -3226,7 +3226,7 @@
                 <a:ea typeface="Times New Roman" pitchFamily="34" charset="-122"/>
                 <a:cs typeface="Times New Roman" pitchFamily="34" charset="-120"/>
               </a:rPr>
-              <a:t>Βασικά δομικά στοιχεία που μοντελοποιεί:</a:t>
+              <a:t>Τι μοντελοποιεί:</a:t>
             </a:r>
             <a:endParaRPr lang="en-US" sz="1450" dirty="0"/>
           </a:p>
@@ -3318,7 +3318,7 @@
                 <a:ea typeface="Times New Roman" pitchFamily="34" charset="-122"/>
                 <a:cs typeface="Times New Roman" pitchFamily="34" charset="-120"/>
               </a:rPr>
-              <a:t>πίνακες ACPI (MCFG, DSDT, CEDT, SRAT) για ανακάλυψη της τοπολογίας.</a:t>
+              <a:t>ACPI tables (MCFG, DSDT, CEDT, SRAT) για το discovery της τοπολογίας.</a:t>
             </a:r>
             <a:endParaRPr lang="en-US" sz="1400" dirty="0"/>
           </a:p>
@@ -3410,7 +3410,7 @@
                 <a:ea typeface="Times New Roman" pitchFamily="34" charset="-122"/>
                 <a:cs typeface="Times New Roman" pitchFamily="34" charset="-120"/>
               </a:rPr>
-              <a:t>Root Complex και σύνολα καταχωρητών για απαρίθμηση της συσκευής.</a:t>
+              <a:t>Root Complex και registers για το enumeration της συσκευής.</a:t>
             </a:r>
             <a:endParaRPr lang="en-US" sz="1400" dirty="0"/>
           </a:p>
@@ -3502,7 +3502,7 @@
                 <a:ea typeface="Times New Roman" pitchFamily="34" charset="-122"/>
                 <a:cs typeface="Times New Roman" pitchFamily="34" charset="-120"/>
               </a:rPr>
-              <a:t>επίπεδο συναλλαγών με κανάλια M2S / S2M και πακετοποίηση στα άκρα.</a:t>
+              <a:t>transaction layer με M2S / S2M channels και packetization στα άκρα.</a:t>
             </a:r>
             <a:endParaRPr lang="en-US" sz="1400" dirty="0"/>
           </a:p>
@@ -3580,7 +3580,7 @@
                 <a:ea typeface="Courier New" pitchFamily="34" charset="-122"/>
                 <a:cs typeface="Courier New" pitchFamily="34" charset="-120"/>
               </a:rPr>
-              <a:t>Συνοχή. </a:t>
+              <a:t>Coherence. </a:t>
             </a:r>
             <a:pPr indent="0" marL="0">
               <a:buNone/>
@@ -3594,7 +3594,7 @@
                 <a:ea typeface="Times New Roman" pitchFamily="34" charset="-122"/>
                 <a:cs typeface="Times New Roman" pitchFamily="34" charset="-120"/>
               </a:rPr>
-              <a:t>πρωτόκολλο MESI δύο επιπέδων με κατανεμημένο κατάλογο (Ruby).</a:t>
+              <a:t>MESI δύο επιπέδων με directory (Ruby).</a:t>
             </a:r>
             <a:endParaRPr lang="en-US" sz="1400" dirty="0"/>
           </a:p>
@@ -3653,7 +3653,7 @@
                 <a:ea typeface="Times New Roman" pitchFamily="34" charset="-122"/>
                 <a:cs typeface="Times New Roman" pitchFamily="34" charset="-120"/>
               </a:rPr>
-              <a:t>Πού παρεμβάλλεται ο κώδικας της εργασίας</a:t>
+              <a:t>Πού μπαίνει ο δικός μου κώδικας</a:t>
             </a:r>
             <a:endParaRPr lang="en-US" sz="1450" dirty="0"/>
           </a:p>
@@ -3695,7 +3695,7 @@
                 <a:ea typeface="Times New Roman" pitchFamily="34" charset="-122"/>
                 <a:cs typeface="Times New Roman" pitchFamily="34" charset="-120"/>
               </a:rPr>
-              <a:t>Στο σημείο όπου ο κόμβος CXL απο-πακετοποιεί ένα αίτημα M2S σε προσπέλαση της DRAM, διατίθεται η πλειάδα {φυσική διεύθυνση, ανάγνωση/εγγραφή, χρονική στιγμή}. Αυτή είναι ακριβώς η ροή αστοχιών LLC προς τη CXL την οποία κάνουν profiling τα NeoMem και M5· τίποτε άλλο δεν είναι ορατό από εκεί. Ο profiler υλοποιείται ως λήψη (tap) πάνω σε αυτό το μονοπάτι αιτημάτων.</a:t>
+              <a:t>Εκεί που ο CXL node κάνει de-packetize ένα M2S request σε access στη DRAM, έχω το triple {physical address, read/write, timestamp}. Αυτό είναι ακριβώς το stream των LLC misses προς την CXL που κάνουν profiling το NeoMem και το M5· τίποτα άλλο δεν φαίνεται από εκεί. Ο profiler μπαίνει σαν tap πάνω σε αυτό το path.</a:t>
             </a:r>
             <a:endParaRPr lang="en-US" sz="1350" dirty="0"/>
           </a:p>
@@ -3780,7 +3780,7 @@
                 <a:ea typeface="Times New Roman" pitchFamily="34" charset="-122"/>
                 <a:cs typeface="Times New Roman" pitchFamily="34" charset="-120"/>
               </a:rPr>
-              <a:t>Σχέδιο πειράματος</a:t>
+              <a:t>Σχέδιο του πειράματος</a:t>
             </a:r>
             <a:endParaRPr lang="en-US" sz="2400" dirty="0"/>
           </a:p>
@@ -3956,7 +3956,7 @@
                 <a:ea typeface="Times New Roman" pitchFamily="34" charset="-122"/>
                 <a:cs typeface="Times New Roman" pitchFamily="34" charset="-120"/>
               </a:rPr>
-              <a:t>Πέντε σκέλη σύγκρισης.</a:t>
+              <a:t>Πέντε cases για σύγκριση.</a:t>
             </a:r>
             <a:endParaRPr lang="en-US" sz="1500" dirty="0"/>
           </a:p>
@@ -4010,7 +4010,7 @@
         <p:spPr>
           <a:xfrm>
             <a:off x="1143000" y="1664208"/>
-            <a:ext cx="4937760" cy="310896"/>
+            <a:ext cx="5029200" cy="310896"/>
           </a:xfrm>
           <a:prstGeom prst="rect">
             <a:avLst/>
@@ -4034,7 +4034,7 @@
                 <a:ea typeface="Times New Roman" pitchFamily="34" charset="-122"/>
                 <a:cs typeface="Times New Roman" pitchFamily="34" charset="-120"/>
               </a:rPr>
-              <a:t>Όλα σε CXL</a:t>
+              <a:t>Όλα στην CXL</a:t>
             </a:r>
             <a:pPr indent="0" marL="0">
               <a:buNone/>
@@ -4048,7 +4048,7 @@
                 <a:ea typeface="Times New Roman" pitchFamily="34" charset="-122"/>
                 <a:cs typeface="Times New Roman" pitchFamily="34" charset="-120"/>
               </a:rPr>
-              <a:t>  — κάτω φράγμα</a:t>
+              <a:t>  — lower bound</a:t>
             </a:r>
             <a:endParaRPr lang="en-US" sz="1400" dirty="0"/>
           </a:p>
@@ -4102,7 +4102,7 @@
         <p:spPr>
           <a:xfrm>
             <a:off x="1143000" y="2066544"/>
-            <a:ext cx="4937760" cy="310896"/>
+            <a:ext cx="5029200" cy="310896"/>
           </a:xfrm>
           <a:prstGeom prst="rect">
             <a:avLst/>
@@ -4140,7 +4140,7 @@
                 <a:ea typeface="Times New Roman" pitchFamily="34" charset="-122"/>
                 <a:cs typeface="Times New Roman" pitchFamily="34" charset="-120"/>
               </a:rPr>
-              <a:t>  — άνω φράγμα</a:t>
+              <a:t>  — upper bound</a:t>
             </a:r>
             <a:endParaRPr lang="en-US" sz="1400" dirty="0"/>
           </a:p>
@@ -4194,7 +4194,7 @@
         <p:spPr>
           <a:xfrm>
             <a:off x="1143000" y="2468880"/>
-            <a:ext cx="4937760" cy="310896"/>
+            <a:ext cx="5029200" cy="310896"/>
           </a:xfrm>
           <a:prstGeom prst="rect">
             <a:avLst/>
@@ -4218,7 +4218,7 @@
                 <a:ea typeface="Times New Roman" pitchFamily="34" charset="-122"/>
                 <a:cs typeface="Times New Roman" pitchFamily="34" charset="-120"/>
               </a:rPr>
-              <a:t>Αφελής μετανάστευση σελίδων</a:t>
+              <a:t>Απλό page migration</a:t>
             </a:r>
             <a:pPr indent="0" marL="0">
               <a:buNone/>
@@ -4286,7 +4286,7 @@
         <p:spPr>
           <a:xfrm>
             <a:off x="1143000" y="2871216"/>
-            <a:ext cx="4937760" cy="310896"/>
+            <a:ext cx="5029200" cy="310896"/>
           </a:xfrm>
           <a:prstGeom prst="rect">
             <a:avLst/>
@@ -4310,7 +4310,7 @@
                 <a:ea typeface="Times New Roman" pitchFamily="34" charset="-122"/>
                 <a:cs typeface="Times New Roman" pitchFamily="34" charset="-120"/>
               </a:rPr>
-              <a:t>Σχήμα του M5 (HPT + HWT)</a:t>
+              <a:t>Ο μηχανισμός του M5 (HPT + HWT)</a:t>
             </a:r>
             <a:pPr indent="0" marL="0">
               <a:buNone/>
@@ -4378,7 +4378,7 @@
         <p:spPr>
           <a:xfrm>
             <a:off x="1143000" y="3273552"/>
-            <a:ext cx="4937760" cy="310896"/>
+            <a:ext cx="5029200" cy="310896"/>
           </a:xfrm>
           <a:prstGeom prst="rect">
             <a:avLst/>
@@ -4402,7 +4402,7 @@
                 <a:ea typeface="Times New Roman" pitchFamily="34" charset="-122"/>
                 <a:cs typeface="Times New Roman" pitchFamily="34" charset="-120"/>
               </a:rPr>
-              <a:t>Oracle τοποθέτηση</a:t>
+              <a:t>Oracle placement</a:t>
             </a:r>
             <a:pPr indent="0" marL="0">
               <a:buNone/>
@@ -4416,7 +4416,7 @@
                 <a:ea typeface="Times New Roman" pitchFamily="34" charset="-122"/>
                 <a:cs typeface="Times New Roman" pitchFamily="34" charset="-120"/>
               </a:rPr>
-              <a:t>  — βέλτιστο offline</a:t>
+              <a:t>  — offline βέλτιστο</a:t>
             </a:r>
             <a:endParaRPr lang="en-US" sz="1400" dirty="0"/>
           </a:p>
@@ -4458,7 +4458,7 @@
                 <a:ea typeface="Times New Roman" pitchFamily="34" charset="-122"/>
                 <a:cs typeface="Times New Roman" pitchFamily="34" charset="-120"/>
               </a:rPr>
-              <a:t>Η απόσταση μεταξύ του αφελούς σκέλους και του oracle είναι, επακριβώς, το πρόβλημα που αναπαράγεται.</a:t>
+              <a:t>Η απόσταση ανάμεσα στο απλό migration και στο oracle είναι ακριβώς το πρόβλημα που θέλω να δείξω.</a:t>
             </a:r>
             <a:endParaRPr lang="en-US" sz="1400" dirty="0"/>
           </a:p>
@@ -4517,7 +4517,7 @@
                 <a:ea typeface="Times New Roman" pitchFamily="34" charset="-122"/>
                 <a:cs typeface="Times New Roman" pitchFamily="34" charset="-120"/>
               </a:rPr>
-              <a:t>Φόρτοι εργασίας.</a:t>
+              <a:t>Workloads.</a:t>
             </a:r>
             <a:endParaRPr lang="en-US" sz="1500" dirty="0"/>
           </a:p>
@@ -4576,7 +4576,7 @@
                 <a:ea typeface="Times New Roman" pitchFamily="34" charset="-122"/>
                 <a:cs typeface="Times New Roman" pitchFamily="34" charset="-120"/>
               </a:rPr>
-              <a:t> — τυχαίες ενημερώσεις 8 B, μηδενική χωρική τοπικότητα (η αντίπαλη περίπτωση)
+              <a:t> — τυχαία 8 B updates, μηδέν spatial locality (η χειρότερη περίπτωση)
 </a:t>
             </a:r>
             <a:pPr indent="0" marL="0">
@@ -4611,7 +4611,7 @@
                 <a:ea typeface="Times New Roman" pitchFamily="34" charset="-122"/>
                 <a:cs typeface="Times New Roman" pitchFamily="34" charset="-120"/>
               </a:rPr>
-              <a:t> — αναζητήσεις Monte Carlo σε μεγάλους πίνακες
+              <a:t> — Monte Carlo lookups σε μεγάλα tables
 </a:t>
             </a:r>
             <a:pPr indent="0" marL="0">
@@ -4646,7 +4646,7 @@
                 <a:ea typeface="Times New Roman" pitchFamily="34" charset="-122"/>
                 <a:cs typeface="Times New Roman" pitchFamily="34" charset="-120"/>
               </a:rPr>
-              <a:t> — άτακτη προσπέλαση γράφου, μετακινούμενο θερμό σύνολο
+              <a:t> — irregular graph access, το hot set μετακινείται
 </a:t>
             </a:r>
             <a:pPr indent="0" marL="0">
@@ -4681,7 +4681,7 @@
                 <a:ea typeface="Times New Roman" pitchFamily="34" charset="-122"/>
                 <a:cs typeface="Times New Roman" pitchFamily="34" charset="-120"/>
               </a:rPr>
-              <a:t> — κατανομή Zipf, ακραία υπο-σελιδική θερμότητα</a:t>
+              <a:t> — Zipf, ακραίο sub-page hotness</a:t>
             </a:r>
             <a:endParaRPr lang="en-US" sz="1350" dirty="0"/>
           </a:p>
@@ -4720,7 +4720,7 @@
                 <a:ea typeface="Times New Roman" pitchFamily="34" charset="-122"/>
                 <a:cs typeface="Times New Roman" pitchFamily="34" charset="-120"/>
               </a:rPr>
-              <a:t>Μετρικές.</a:t>
+              <a:t>Metrics.</a:t>
             </a:r>
             <a:endParaRPr lang="en-US" sz="1500" dirty="0"/>
           </a:p>
@@ -4762,7 +4762,7 @@
                 <a:ea typeface="Times New Roman" pitchFamily="34" charset="-122"/>
                 <a:cs typeface="Times New Roman" pitchFamily="34" charset="-120"/>
               </a:rPr>
-              <a:t>– αθροιστική κατανομή πυκνότητας προσπελάσεων ανά γραμμή 64 B
+              <a:t>– CDF του access density ανά 64 B line
 </a:t>
             </a:r>
             <a:pPr indent="0" marL="0">
@@ -4780,7 +4780,7 @@
                 <a:ea typeface="Times New Roman" pitchFamily="34" charset="-122"/>
                 <a:cs typeface="Times New Roman" pitchFamily="34" charset="-120"/>
               </a:rPr>
-              <a:t>– απόδοση μεταφοράς: bytes που μεταφέρθηκαν ÷ bytes που χρησιμοποιήθηκαν
+              <a:t>– migration efficiency: bytes που μετακινήθηκαν ÷ bytes που όντως χρησιμοποιήθηκαν
 </a:t>
             </a:r>
             <a:pPr indent="0" marL="0">
@@ -4798,7 +4798,7 @@
                 <a:ea typeface="Times New Roman" pitchFamily="34" charset="-122"/>
                 <a:cs typeface="Times New Roman" pitchFamily="34" charset="-120"/>
               </a:rPr>
-              <a:t>– επικαιρότητα προαγωγής και ποσοστό σελίδων ακόμη θερμών κατά την προαγωγή
+              <a:t>– promotion timeliness· πόσα pages είναι ακόμα hot την ώρα του promotion
 </a:t>
             </a:r>
             <a:pPr indent="0" marL="0">
@@ -4816,7 +4816,7 @@
                 <a:ea typeface="Times New Roman" pitchFamily="34" charset="-122"/>
                 <a:cs typeface="Times New Roman" pitchFamily="34" charset="-120"/>
               </a:rPr>
-              <a:t>– επιβράδυνση συναρτήσει του λόγου βαθμίδων· πλήθος ταλαντώσεων (ping-pong)</a:t>
+              <a:t>– slowdown vs το fast-tier ratio· αριθμός από ping-pongs</a:t>
             </a:r>
             <a:endParaRPr lang="en-US" sz="1300" dirty="0"/>
           </a:p>
@@ -4901,7 +4901,7 @@
                 <a:ea typeface="Times New Roman" pitchFamily="34" charset="-122"/>
                 <a:cs typeface="Times New Roman" pitchFamily="34" charset="-120"/>
               </a:rPr>
-              <a:t>Το ζητούμενο σχήμα</a:t>
+              <a:t>Το σχήμα που θα το κρίνει</a:t>
             </a:r>
             <a:endParaRPr lang="en-US" sz="2400" dirty="0"/>
           </a:p>
@@ -5080,7 +5080,7 @@
                 <a:ea typeface="Times New Roman" pitchFamily="34" charset="-122"/>
                 <a:cs typeface="Times New Roman" pitchFamily="34" charset="-120"/>
               </a:rPr>
-              <a:t>Για κάθε σελίδα 4 KB μετράμε τι ποσοστό των προσπελάσεών της συγκεντρώνεται στις k θερμότερες γραμμές των 64 B. Αν το 80% των προσπελάσεων πέφτει σε λιγότερο από το 10% της σελίδας, το επιχείρημα της κοκκομέτρησης αποδεικνύεται σε ένα και μόνο διάγραμμα (Σχήμα 3).</a:t>
+              <a:t>Για κάθε page 4 KB μετράω τι ποσοστό των accesses του πέφτει στις k πιο hot 64 B lines. Αν το 80% των accesses πέφτει σε λιγότερο από 10% του page, το επιχείρημα του granularity αποδεικνύεται με ένα μόνο γράφημα (Σχήμα 3).</a:t>
             </a:r>
             <a:endParaRPr lang="en-US" sz="1500" dirty="0"/>
           </a:p>
@@ -5139,7 +5139,7 @@
                 <a:ea typeface="Times New Roman" pitchFamily="34" charset="-122"/>
                 <a:cs typeface="Times New Roman" pitchFamily="34" charset="-120"/>
               </a:rPr>
-              <a:t>Η καμπύλη είναι η αναμενόμενη μορφή, όχι μετρημένα δεδομένα· ο προσομοιωτής δεν έχει ακόμη εκτελεστεί. Αν βγει επίπεδη, το επιχείρημα της υπο-σελιδικής θερμότητας καταρρέει για τον φόρτο αυτόν — αποτέλεσμα εξίσου χρήσιμο.</a:t>
+              <a:t>Η καμπύλη είναι το αναμενόμενο σχήμα, όχι πραγματικά δεδομένα· ο προσομοιωτής δεν έχει τρέξει ακόμα. Αν βγει επίπεδη, το επιχείρημα του sub-page hotness πέφτει για αυτό το workload — που είναι εξίσου χρήσιμο αποτέλεσμα.</a:t>
             </a:r>
             <a:endParaRPr lang="en-US" sz="1400" dirty="0"/>
           </a:p>
@@ -5208,7 +5208,7 @@
                 <a:ea typeface="Times New Roman" pitchFamily="34" charset="-122"/>
                 <a:cs typeface="Times New Roman" pitchFamily="34" charset="-120"/>
               </a:rPr>
-              <a:t>αθροιστικό ποσοστό προσπελάσεων στις k θερμότερες γραμμές 64 B (αναμενόμενη μορφή).</a:t>
+              <a:t>cumulative % των accesses στις k πιο hot 64 B lines (αναμενόμενο σχήμα).</a:t>
             </a:r>
             <a:endParaRPr lang="en-US" sz="1100" dirty="0"/>
           </a:p>
@@ -5293,7 +5293,7 @@
                 <a:ea typeface="Times New Roman" pitchFamily="34" charset="-122"/>
                 <a:cs typeface="Times New Roman" pitchFamily="34" charset="-120"/>
               </a:rPr>
-              <a:t>Φάσεις υλοποίησης και διαχείριση ρίσκου</a:t>
+              <a:t>Φάσεις υλοποίησης και ρίσκο</a:t>
             </a:r>
             <a:endParaRPr lang="en-US" sz="2400" dirty="0"/>
           </a:p>
@@ -5511,7 +5511,7 @@
                 <a:ea typeface="Times New Roman" pitchFamily="34" charset="-122"/>
                 <a:cs typeface="Times New Roman" pitchFamily="34" charset="-120"/>
               </a:rPr>
-              <a:t>Εκκίνηση και checkpoint. </a:t>
+              <a:t>Boot &amp; checkpoint. </a:t>
             </a:r>
             <a:pPr algn="just" indent="0" marL="0">
               <a:lnSpc>
@@ -5528,7 +5528,7 @@
                 <a:ea typeface="Times New Roman" pitchFamily="34" charset="-122"/>
                 <a:cs typeface="Times New Roman" pitchFamily="34" charset="-120"/>
               </a:rPr>
-              <a:t>Boot έως shell, επιβεβαίωση κόμβου zNUMA, microbenchmark καθυστέρησης («απόδειξη ότι η CXL είναι αργή»).</a:t>
+              <a:t>Boot μέχρι shell, επιβεβαίωση του zNUMA node, latency microbenchmark («να δείξω ότι η CXL είναι όντως πιο αργή»).</a:t>
             </a:r>
             <a:endParaRPr lang="en-US" sz="1450" dirty="0"/>
           </a:p>
@@ -5629,7 +5629,7 @@
                 <a:ea typeface="Times New Roman" pitchFamily="34" charset="-122"/>
                 <a:cs typeface="Times New Roman" pitchFamily="34" charset="-120"/>
               </a:rPr>
-              <a:t>Λήψη ιχνών προσπέλασης. </a:t>
+              <a:t>Access tracing. </a:t>
             </a:r>
             <a:pPr algn="just" indent="0" marL="0">
               <a:lnSpc>
@@ -5646,7 +5646,7 @@
                 <a:ea typeface="Times New Roman" pitchFamily="34" charset="-122"/>
                 <a:cs typeface="Times New Roman" pitchFamily="34" charset="-120"/>
               </a:rPr>
-              <a:t>Σημείο λήψης στη ροή αιτημάτων της συσκευής και κατανομή πυκνότητας — το πρώτο πραγματικό αποτέλεσμα.</a:t>
+              <a:t>Tap στο request stream της συσκευής και CDF του access density — το πρώτο πραγματικό αποτέλεσμα.</a:t>
             </a:r>
             <a:endParaRPr lang="en-US" sz="1450" dirty="0"/>
           </a:p>
@@ -5747,7 +5747,7 @@
                 <a:ea typeface="Times New Roman" pitchFamily="34" charset="-122"/>
                 <a:cs typeface="Times New Roman" pitchFamily="34" charset="-120"/>
               </a:rPr>
-              <a:t>Βασική γραμμή μετανάστευσης. </a:t>
+              <a:t>Baseline migration. </a:t>
             </a:r>
             <a:pPr algn="just" indent="0" marL="0">
               <a:lnSpc>
@@ -5764,7 +5764,7 @@
                 <a:ea typeface="Times New Roman" pitchFamily="34" charset="-122"/>
                 <a:cs typeface="Times New Roman" pitchFamily="34" charset="-120"/>
               </a:rPr>
-              <a:t>Αφελής μετανάστευση σελίδων με έντιμο μοντέλο κόστους και ποσόστωση εύρους ζώνης.</a:t>
+              <a:t>Απλό page migration με τίμιο cost model και bandwidth quota.</a:t>
             </a:r>
             <a:endParaRPr lang="en-US" sz="1450" dirty="0"/>
           </a:p>
@@ -5865,7 +5865,7 @@
                 <a:ea typeface="Times New Roman" pitchFamily="34" charset="-122"/>
                 <a:cs typeface="Times New Roman" pitchFamily="34" charset="-120"/>
               </a:rPr>
-              <a:t>Υλοποίηση M5. </a:t>
+              <a:t>Υλοποίηση του M5. </a:t>
             </a:r>
             <a:pPr algn="just" indent="0" marL="0">
               <a:lnSpc>
@@ -5882,7 +5882,7 @@
                 <a:ea typeface="Times New Roman" pitchFamily="34" charset="-122"/>
                 <a:cs typeface="Times New Roman" pitchFamily="34" charset="-120"/>
               </a:rPr>
-              <a:t>Πρώτα ο HPT (θερμές σελίδες), κατόπιν ο HWT (θερμές λέξεις 64 B) ως το διαφοροποιητικό στοιχείο.</a:t>
+              <a:t>Πρώτα ο HPT (hot pages), μετά ο HWT (hot 64 B words) σαν το κομμάτι που κάνει τη διαφορά.</a:t>
             </a:r>
             <a:endParaRPr lang="en-US" sz="1450" dirty="0"/>
           </a:p>
@@ -5983,7 +5983,7 @@
                 <a:ea typeface="Times New Roman" pitchFamily="34" charset="-122"/>
                 <a:cs typeface="Times New Roman" pitchFamily="34" charset="-120"/>
               </a:rPr>
-              <a:t>Αξιολόγηση και συγγραφή. </a:t>
+              <a:t>Evaluation &amp; γράψιμο. </a:t>
             </a:r>
             <a:pPr algn="just" indent="0" marL="0">
               <a:lnSpc>
@@ -6000,7 +6000,7 @@
                 <a:ea typeface="Times New Roman" pitchFamily="34" charset="-122"/>
                 <a:cs typeface="Times New Roman" pitchFamily="34" charset="-120"/>
               </a:rPr>
-              <a:t>Ανάλυση ευαισθησίας ως προς K, διάστημα, ποσόστωση και καθυστέρηση CXL.</a:t>
+              <a:t>Sensitivity ως προς K, interval, quota, CXL latency.</a:t>
             </a:r>
             <a:endParaRPr lang="en-US" sz="1450" dirty="0"/>
           </a:p>
@@ -6042,7 +6042,7 @@
                 <a:ea typeface="Times New Roman" pitchFamily="34" charset="-122"/>
                 <a:cs typeface="Times New Roman" pitchFamily="34" charset="-120"/>
               </a:rPr>
-              <a:t>Η Φάση 2 απομειώνει το ρίσκο όλων των υπολοίπων, παράγοντας παρουσιάσιμο αποτέλεσμα πριν γραφτεί οποιαδήποτε πολιτική. Προαιρετικές επεκτάσεις: μοντέλο κόστους υλικού, σάρωση καθυστέρησης, δύο συντρέχοντες φόρτοι.</a:t>
+              <a:t>Η Φάση 2 μειώνει το ρίσκο όλων των υπολοίπων: βγάζει παρουσιάσιμο αποτέλεσμα πριν γραφτεί οποιοδήποτε policy. Προαιρετικά: hardware cost model, latency sweep, δύο workloads μαζί.</a:t>
             </a:r>
             <a:endParaRPr lang="en-US" sz="1400" dirty="0"/>
           </a:p>
@@ -6127,7 +6127,7 @@
                 <a:ea typeface="Times New Roman" pitchFamily="34" charset="-122"/>
                 <a:cs typeface="Times New Roman" pitchFamily="34" charset="-120"/>
               </a:rPr>
-              <a:t>Ανοιχτά ερωτήματα προς συζήτηση</a:t>
+              <a:t>Ανοιχτά ερωτήματα για συζήτηση</a:t>
             </a:r>
             <a:endParaRPr lang="en-US" sz="2400" dirty="0"/>
           </a:p>
@@ -6384,7 +6384,7 @@
                 <a:ea typeface="Times New Roman" pitchFamily="34" charset="-122"/>
                 <a:cs typeface="Times New Roman" pitchFamily="34" charset="-120"/>
               </a:rPr>
-              <a:t>Υπάρχει διαθέσιμο αποθετήριο και οδηγίες build; Ιδανικά και έτοιμο disk image — το χτίσιμο από το μηδέν είναι παράκαμψη ημερών που δεν διδάσκει τίποτε για το tiering.</a:t>
+              <a:t>Υπάρχει repo και οδηγίες build; Ιδανικά και έτοιμο disk image — το να το χτίσω από το μηδέν είναι μέρες δουλειάς που δεν διδάσκουν κάτι για το tiering.</a:t>
             </a:r>
             <a:endParaRPr lang="en-US" sz="1400" dirty="0"/>
           </a:p>
@@ -6462,7 +6462,7 @@
                 <a:ea typeface="Times New Roman" pitchFamily="34" charset="-122"/>
                 <a:cs typeface="Times New Roman" pitchFamily="34" charset="-120"/>
               </a:rPr>
-              <a:t>Κλίμακα φόρτων.</a:t>
+              <a:t>Μέγεθος των workloads.</a:t>
             </a:r>
             <a:endParaRPr lang="en-US" sz="1600" dirty="0"/>
           </a:p>
@@ -6504,7 +6504,7 @@
                 <a:ea typeface="Times New Roman" pitchFamily="34" charset="-122"/>
                 <a:cs typeface="Times New Roman" pitchFamily="34" charset="-120"/>
               </a:rPr>
-              <a:t>Είναι αποδεκτό να μειωθεί το μέγεθος σε εκατοντάδες MB αντί για 10–20 GB RSS, διατηρώντας ρεαλιστικό τον λόγο των βαθμίδων;</a:t>
+              <a:t>Είναι ok να κατεβάσω το μέγεθος σε εκατοντάδες MB αντί για 10–20 GB RSS, κρατώντας ρεαλιστικό το ratio των tiers;</a:t>
             </a:r>
             <a:endParaRPr lang="en-US" sz="1400" dirty="0"/>
           </a:p>
@@ -6582,7 +6582,7 @@
                 <a:ea typeface="Times New Roman" pitchFamily="34" charset="-122"/>
                 <a:cs typeface="Times New Roman" pitchFamily="34" charset="-120"/>
               </a:rPr>
-              <a:t>Εύρος υλοποίησης.</a:t>
+              <a:t>Πόσο μακριά να πάει το implementation.</a:t>
             </a:r>
             <a:endParaRPr lang="en-US" sz="1600" dirty="0"/>
           </a:p>
@@ -6624,7 +6624,7 @@
                 <a:ea typeface="Times New Roman" pitchFamily="34" charset="-122"/>
                 <a:cs typeface="Times New Roman" pitchFamily="34" charset="-120"/>
               </a:rPr>
-              <a:t>Αρκεί profiler HPT+HWT με μοντελοποιημένη μηχανή μετανάστευσης, ή ζητείται πραγματική μετανάστευση Linux οδηγούμενη από kernel module;</a:t>
+              <a:t>Φτάνει profiler HPT+HWT με μοντελοποιημένο migration engine, ή θέλετε πραγματικό Linux migration από kernel module;</a:t>
             </a:r>
             <a:endParaRPr lang="en-US" sz="1400" dirty="0"/>
           </a:p>
@@ -6702,7 +6702,7 @@
                 <a:ea typeface="Times New Roman" pitchFamily="34" charset="-122"/>
                 <a:cs typeface="Times New Roman" pitchFamily="34" charset="-120"/>
               </a:rPr>
-              <a:t>Επιλογή εργασίας.</a:t>
+              <a:t>Επιλογή paper.</a:t>
             </a:r>
             <a:endParaRPr lang="en-US" sz="1600" dirty="0"/>
           </a:p>
@@ -6744,7 +6744,7 @@
                 <a:ea typeface="Times New Roman" pitchFamily="34" charset="-122"/>
                 <a:cs typeface="Times New Roman" pitchFamily="34" charset="-120"/>
               </a:rPr>
-              <a:t>Είναι το M5 η ενδεδειγμένη επιλογή, ή προτιμάται υλοποίηση του NeoMem;</a:t>
+              <a:t>Είναι το M5 η σωστή επιλογή, ή προτιμάτε να δείτε NeoMem;</a:t>
             </a:r>
             <a:endParaRPr lang="en-US" sz="1400" dirty="0"/>
           </a:p>
@@ -6829,7 +6829,7 @@
                 <a:ea typeface="Times New Roman" pitchFamily="34" charset="-122"/>
                 <a:cs typeface="Times New Roman" pitchFamily="34" charset="-120"/>
               </a:rPr>
-              <a:t>Η μνήμη είναι ο περιοριστικός πόρος</a:t>
+              <a:t>Η μνήμη είναι το bottleneck</a:t>
             </a:r>
             <a:endParaRPr lang="en-US" sz="2400" dirty="0"/>
           </a:p>
@@ -7008,7 +7008,7 @@
                 <a:ea typeface="Times New Roman" pitchFamily="34" charset="-122"/>
                 <a:cs typeface="Times New Roman" pitchFamily="34" charset="-120"/>
               </a:rPr>
-              <a:t>Η χωρητικότητα της μνήμης ανά επεξεργαστικό socket έχει φτάσει σε τοίχο: περιορισμένος αριθμός από DIMM slots και pins DDR. Για να αποκτήσει κανείς περισσότερη μνήμη αναγκάζεται να αγοράσει περισσότερους επεξεργαστές τους οποίους δεν χρειάζεται. Το CXL σπάει αυτόν τον δεσμό, επιτρέποντας επέκταση της χωρητικότητας πάνω από τον δίαυλο PCIe, ανεξάρτητα από τους πυρήνες.</a:t>
+              <a:t>Η capacity της μνήμης ανά socket έχει κολλήσει: λίγα DIMM slots, λίγα pins στο DDR. Για να βάλεις παραπάνω μνήμη πρέπει να πάρεις κι άλλους επεξεργαστές που δεν σου χρειάζονται. Το CXL σπάει αυτή τη σχέση: βάζεις μνήμη πάνω από το PCIe, ανεξάρτητα από τα cores.</a:t>
             </a:r>
             <a:endParaRPr lang="en-US" sz="1600" dirty="0"/>
           </a:p>
@@ -7067,7 +7067,7 @@
                 <a:ea typeface="Times New Roman" pitchFamily="34" charset="-122"/>
                 <a:cs typeface="Times New Roman" pitchFamily="34" charset="-120"/>
               </a:rPr>
-              <a:t>Παρατήρηση 1 — αποκομμένη («stranded») μνήμη</a:t>
+              <a:t>Το νούμερο — stranded μνήμη</a:t>
             </a:r>
             <a:endParaRPr lang="en-US" sz="1450" dirty="0"/>
           </a:p>
@@ -7109,7 +7109,7 @@
                 <a:ea typeface="Times New Roman" pitchFamily="34" charset="-122"/>
                 <a:cs typeface="Times New Roman" pitchFamily="34" charset="-120"/>
               </a:rPr>
-              <a:t>Σε στόλους cloud υπερκλίμακας, περίπου το 25% της εγκατεστημένης DRAM παραμένει αναξιοποίητο, επειδή οι πυρήνες του μηχανήματος έχουν ήδη διατεθεί σε άλλους ενοίκους. Το CXL στοχεύει ακριβώς στην ανάκτηση αυτής της αποκομμένης χωρητικότητας (Azure — Pond, ASPLOS ’23).</a:t>
+              <a:t>Σε μεγάλα cloud datacenters, περίπου το 25% της DRAM μένει αχρησιμοποίητο (stranded), γιατί τα cores του μηχανήματος έχουν ήδη νοικιαστεί σε άλλους. Το CXL στοχεύει ακριβώς σε αυτή τη χαμένη capacity (Azure — Pond, ASPLOS ’23).</a:t>
             </a:r>
             <a:endParaRPr lang="en-US" sz="1350" dirty="0"/>
           </a:p>
@@ -7124,7 +7124,7 @@
         <p:spPr>
           <a:xfrm>
             <a:off x="777240" y="4251960"/>
-            <a:ext cx="10634472" cy="822960"/>
+            <a:ext cx="10634472" cy="640080"/>
           </a:xfrm>
           <a:prstGeom prst="rect">
             <a:avLst/>
@@ -7151,7 +7151,7 @@
                 <a:ea typeface="Times New Roman" pitchFamily="34" charset="-122"/>
                 <a:cs typeface="Times New Roman" pitchFamily="34" charset="-120"/>
               </a:rPr>
-              <a:t>Αυτό το οικονομικό κίνητρο —φθηνή, κοινόχρηστη χωρητικότητα— είναι που κάνει το CXL ελκυστικό. Το τεχνικό τίμημα, όμως, είναι η καθυστέρηση προσπέλασης, την οποία εξετάζουμε στη συνέχεια.</a:t>
+              <a:t>Το κίνητρο είναι η φθηνή, κοινή capacity. Το κόστος είναι το latency, που το βλέπουμε στην επόμενη διαφάνεια.</a:t>
             </a:r>
             <a:endParaRPr lang="en-US" sz="1500" dirty="0"/>
           </a:p>
@@ -7236,7 +7236,7 @@
                 <a:ea typeface="Times New Roman" pitchFamily="34" charset="-122"/>
                 <a:cs typeface="Times New Roman" pitchFamily="34" charset="-120"/>
               </a:rPr>
-              <a:t>Το τίμημα: η καθυστέρηση της CXL</a:t>
+              <a:t>Το κόστος: το latency της CXL</a:t>
             </a:r>
             <a:endParaRPr lang="en-US" sz="2400" dirty="0"/>
           </a:p>
@@ -7426,7 +7426,7 @@
                 <a:ea typeface="Times New Roman" pitchFamily="34" charset="-122"/>
                 <a:cs typeface="Times New Roman" pitchFamily="34" charset="-120"/>
               </a:rPr>
-              <a:t>τυπικές τιμές καθυστέρησης και εύρους ζώνης ανά διαδρομή.</a:t>
+              <a:t>τυπικές τιμές latency και bandwidth ανά διαδρομή.</a:t>
             </a:r>
             <a:endParaRPr lang="en-US" sz="1100" dirty="0"/>
           </a:p>
@@ -7521,7 +7521,7 @@
                           <a:ea typeface="Times New Roman" pitchFamily="34" charset="-122"/>
                           <a:cs typeface="Times New Roman" pitchFamily="34" charset="-120"/>
                         </a:rPr>
-                        <a:t>Καθυστέρηση</a:t>
+                        <a:t>Latency</a:t>
                       </a:r>
                       <a:endParaRPr lang="en-US" sz="1350" dirty="0">
                         <a:latin typeface="Times New Roman" charset="0"/>
@@ -7565,7 +7565,7 @@
                           <a:ea typeface="Times New Roman" pitchFamily="34" charset="-122"/>
                           <a:cs typeface="Times New Roman" pitchFamily="34" charset="-120"/>
                         </a:rPr>
-                        <a:t>Εύρος ζώνης</a:t>
+                        <a:t>Bandwidth</a:t>
                       </a:r>
                       <a:endParaRPr lang="en-US" sz="1350" dirty="0">
                         <a:latin typeface="Times New Roman" charset="0"/>
@@ -7745,7 +7745,7 @@
                           <a:ea typeface="Times New Roman" pitchFamily="34" charset="-122"/>
                           <a:cs typeface="Times New Roman" pitchFamily="34" charset="-120"/>
                         </a:rPr>
-                        <a:t>Απομακρ. NUMA socket</a:t>
+                        <a:t>Άλλο NUMA socket</a:t>
                       </a:r>
                       <a:endParaRPr lang="en-US" sz="1350" dirty="0">
                         <a:latin typeface="Times New Roman" charset="0"/>
@@ -7879,7 +7879,7 @@
                           <a:ea typeface="Times New Roman" pitchFamily="34" charset="-122"/>
                           <a:cs typeface="Times New Roman" pitchFamily="34" charset="-120"/>
                         </a:rPr>
-                        <a:t>Μνήμη CXL (x8 Gen5)</a:t>
+                        <a:t>CXL (x8 Gen5)</a:t>
                       </a:r>
                       <a:endParaRPr lang="en-US" sz="1350" dirty="0">
                         <a:latin typeface="Times New Roman" charset="0"/>
@@ -8095,7 +8095,7 @@
                 <a:ea typeface="Times New Roman" pitchFamily="34" charset="-122"/>
                 <a:cs typeface="Times New Roman" pitchFamily="34" charset="-120"/>
               </a:rPr>
-              <a:t>Η καθυστέρηση είναι </a:t>
+              <a:t>Το latency είναι </a:t>
             </a:r>
             <a:pPr algn="just" indent="0" marL="0">
               <a:lnSpc>
@@ -8112,7 +8112,7 @@
                 <a:ea typeface="Times New Roman" pitchFamily="34" charset="-122"/>
                 <a:cs typeface="Times New Roman" pitchFamily="34" charset="-120"/>
               </a:rPr>
-              <a:t>2–3× μεγαλύτερη</a:t>
+              <a:t>2–3× μεγαλύτερο</a:t>
             </a:r>
             <a:pPr algn="just" indent="0" marL="0">
               <a:lnSpc>
@@ -8129,41 +8129,7 @@
                 <a:ea typeface="Times New Roman" pitchFamily="34" charset="-122"/>
                 <a:cs typeface="Times New Roman" pitchFamily="34" charset="-120"/>
               </a:rPr>
-              <a:t> από την τοπική DDR — παρότι η DRAM πάνω στην κάρτα είναι κοινή DDR5. Το τίμημα το πληρώνει η </a:t>
-            </a:r>
-            <a:pPr algn="just" indent="0" marL="0">
-              <a:lnSpc>
-                <a:spcPts val="2300"/>
-              </a:lnSpc>
-              <a:buNone/>
-            </a:pPr>
-            <a:r>
-              <a:rPr lang="en-US" sz="1500" i="1" dirty="0">
-                <a:solidFill>
-                  <a:srgbClr val="1A1A1A"/>
-                </a:solidFill>
-                <a:latin typeface="Times New Roman" pitchFamily="34" charset="0"/>
-                <a:ea typeface="Times New Roman" pitchFamily="34" charset="-122"/>
-                <a:cs typeface="Times New Roman" pitchFamily="34" charset="-120"/>
-              </a:rPr>
-              <a:t>διασύνδεση</a:t>
-            </a:r>
-            <a:pPr algn="just" indent="0" marL="0">
-              <a:lnSpc>
-                <a:spcPts val="2300"/>
-              </a:lnSpc>
-              <a:buNone/>
-            </a:pPr>
-            <a:r>
-              <a:rPr lang="en-US" sz="1500" dirty="0">
-                <a:solidFill>
-                  <a:srgbClr val="1A1A1A"/>
-                </a:solidFill>
-                <a:latin typeface="Times New Roman" pitchFamily="34" charset="0"/>
-                <a:ea typeface="Times New Roman" pitchFamily="34" charset="-122"/>
-                <a:cs typeface="Times New Roman" pitchFamily="34" charset="-120"/>
-              </a:rPr>
-              <a:t>, όχι η μνήμη. Συνεπώς φόρτοι δεσμευμένοι από καθυστέρηση (pointer chasing) υποφέρουν, ενώ φόρτοι δεσμευμένοι από εύρος ζώνης σχεδόν δεν το αντιλαμβάνονται.</a:t>
+              <a:t> από την τοπική DDR, παρόλο που η DRAM πάνω στην κάρτα είναι κοινή DDR5. Το κόστος το βάζει το interconnect, όχι η μνήμη. Οπότε workloads που είναι latency-bound (pointer chasing) υποφέρουν, ενώ τα bandwidth-bound σχεδόν δεν το καταλαβαίνουν.</a:t>
             </a:r>
             <a:endParaRPr lang="en-US" sz="1500" dirty="0"/>
           </a:p>
@@ -8202,7 +8168,7 @@
                 <a:ea typeface="Times New Roman" pitchFamily="34" charset="-122"/>
                 <a:cs typeface="Times New Roman" pitchFamily="34" charset="-120"/>
               </a:rPr>
-              <a:t>Η διαδρομή ενός load που αστοχεί στην LLC:</a:t>
+              <a:t>Διαδρομή ενός load με LLC miss:</a:t>
             </a:r>
             <a:endParaRPr lang="en-US" sz="1350" dirty="0"/>
           </a:p>
@@ -8280,7 +8246,7 @@
                 <a:ea typeface="Times New Roman" pitchFamily="34" charset="-122"/>
                 <a:cs typeface="Times New Roman" pitchFamily="34" charset="-120"/>
               </a:rPr>
-              <a:t>Πυρήνας CPU  →  αστοχία LLC</a:t>
+              <a:t>Core  →  LLC miss</a:t>
             </a:r>
             <a:endParaRPr lang="en-US" sz="1400" dirty="0"/>
           </a:p>
@@ -8436,7 +8402,7 @@
                 <a:ea typeface="Times New Roman" pitchFamily="34" charset="-122"/>
                 <a:cs typeface="Times New Roman" pitchFamily="34" charset="-120"/>
               </a:rPr>
-              <a:t>πακετοποίηση M2S</a:t>
+              <a:t>packetization (M2S)</a:t>
             </a:r>
             <a:endParaRPr lang="en-US" sz="1400" dirty="0"/>
           </a:p>
@@ -8514,7 +8480,7 @@
                 <a:ea typeface="Times New Roman" pitchFamily="34" charset="-122"/>
                 <a:cs typeface="Times New Roman" pitchFamily="34" charset="-120"/>
               </a:rPr>
-              <a:t>σύνδεσμος PCIe (SERDES)</a:t>
+              <a:t>PCIe link (SERDES)</a:t>
             </a:r>
             <a:endParaRPr lang="en-US" sz="1400" dirty="0"/>
           </a:p>
@@ -8592,7 +8558,7 @@
                 <a:ea typeface="Times New Roman" pitchFamily="34" charset="-122"/>
                 <a:cs typeface="Times New Roman" pitchFamily="34" charset="-120"/>
               </a:rPr>
-              <a:t>ελεγκτής συσκευής  →  de-packetize</a:t>
+              <a:t>device controller  →  de-packetize</a:t>
             </a:r>
             <a:endParaRPr lang="en-US" sz="1400" dirty="0"/>
           </a:p>
@@ -8748,7 +8714,7 @@
                 <a:ea typeface="Times New Roman" pitchFamily="34" charset="-122"/>
                 <a:cs typeface="Times New Roman" pitchFamily="34" charset="-120"/>
               </a:rPr>
-              <a:t>και όλη η διαδρομή αντίστροφα (S2M)</a:t>
+              <a:t>και όλη η διαδρομή πίσω (S2M)</a:t>
             </a:r>
             <a:endParaRPr lang="en-US" sz="1400" dirty="0"/>
           </a:p>
@@ -8801,7 +8767,7 @@
                 <a:ea typeface="Times New Roman" pitchFamily="34" charset="-122"/>
                 <a:cs typeface="Times New Roman" pitchFamily="34" charset="-120"/>
               </a:rPr>
-              <a:t>κάθε στάδιο προσθέτει καθυστέρηση· η διασύνδεση κυριαρχεί.</a:t>
+              <a:t>κάθε στάδιο προσθέτει latency· κυριαρχεί το interconnect.</a:t>
             </a:r>
             <a:endParaRPr lang="en-US" sz="1100" dirty="0"/>
           </a:p>
@@ -9065,7 +9031,7 @@
                 <a:ea typeface="Times New Roman" pitchFamily="34" charset="-122"/>
                 <a:cs typeface="Times New Roman" pitchFamily="34" charset="-120"/>
               </a:rPr>
-              <a:t>Έχουμε δύο βαθμίδες μνήμης — μια γρήγορη και μικρή (τοπική DDR) και μια αργή και μεγάλη (CXL). Σκοπός είναι να διατηρούνται τα «θερμά» δεδομένα στη γρήγορη βαθμίδα. Αν επιτευχθεί, ένα μηχάνημα με μόλις 25% τοπική DRAM αποδίδει σχεδόν σαν να διέθετε 100%.</a:t>
+              <a:t>Έχουμε δύο tiers μνήμης: ένα γρήγορο και μικρό (τοπική DDR) κι ένα αργό και μεγάλο (CXL). Θέλουμε τα hot data να μένουν στο γρήγορο tier. Αν το πετύχεις, ένα μηχάνημα με 25% τοπική DRAM τρέχει σχεδόν σαν να είχε 100%.</a:t>
             </a:r>
             <a:endParaRPr lang="en-US" sz="1600" dirty="0"/>
           </a:p>
@@ -9124,7 +9090,7 @@
                 <a:ea typeface="Times New Roman" pitchFamily="34" charset="-122"/>
                 <a:cs typeface="Times New Roman" pitchFamily="34" charset="-120"/>
               </a:rPr>
-              <a:t>Ορισμός — Προαγωγή (promotion)</a:t>
+              <a:t>Promotion</a:t>
             </a:r>
             <a:endParaRPr lang="en-US" sz="1450" dirty="0"/>
           </a:p>
@@ -9166,7 +9132,7 @@
                 <a:ea typeface="Times New Roman" pitchFamily="34" charset="-122"/>
                 <a:cs typeface="Times New Roman" pitchFamily="34" charset="-120"/>
               </a:rPr>
-              <a:t>Μετακίνηση σελίδας από την αργή στη γρήγορη βαθμίδα. Πρέπει να είναι έγκαιρη: μια σελίδα που προάγεται αφού έχει ήδη κρυώσει αποτελεί καθαρή σπατάλη.</a:t>
+              <a:t>Μετακίνηση ενός page από το αργό στο γρήγορο tier. Πρέπει να γίνει στην ώρα του: αν ένα page προαχθεί αφού έχει κρυώσει, είναι χαμένος κόπος.</a:t>
             </a:r>
             <a:endParaRPr lang="en-US" sz="1350" dirty="0"/>
           </a:p>
@@ -9225,7 +9191,7 @@
                 <a:ea typeface="Times New Roman" pitchFamily="34" charset="-122"/>
                 <a:cs typeface="Times New Roman" pitchFamily="34" charset="-120"/>
               </a:rPr>
-              <a:t>Ορισμός — Υποβάθμιση (demotion)</a:t>
+              <a:t>Demotion</a:t>
             </a:r>
             <a:endParaRPr lang="en-US" sz="1450" dirty="0"/>
           </a:p>
@@ -9267,7 +9233,7 @@
                 <a:ea typeface="Times New Roman" pitchFamily="34" charset="-122"/>
                 <a:cs typeface="Times New Roman" pitchFamily="34" charset="-120"/>
               </a:rPr>
-              <a:t>Μετακίνηση σελίδας από τη γρήγορη στην αργή βαθμίδα. Πρέπει να είναι ασφαλής: η υποβάθμιση μιας ακόμη θερμής σελίδας προκαλεί ταλάντωση (ping-pong).</a:t>
+              <a:t>Μετακίνηση ενός page από το γρήγορο στο αργό tier. Πρέπει να είναι ασφαλής: αν κατεβάσεις ένα page που είναι ακόμα hot, ξεκινάει ping-pong.</a:t>
             </a:r>
             <a:endParaRPr lang="en-US" sz="1350" dirty="0"/>
           </a:p>
@@ -9309,7 +9275,7 @@
                 <a:ea typeface="Times New Roman" pitchFamily="34" charset="-122"/>
                 <a:cs typeface="Times New Roman" pitchFamily="34" charset="-120"/>
               </a:rPr>
-              <a:t>Η υποβάθμιση είναι το εύκολο μέρος — μια προσέγγιση LRU αρκεί, και ο πυρήνας του Linux ήδη διαθέτει LRU. </a:t>
+              <a:t>Το demotion είναι το εύκολο κομμάτι: ένα LRU αρκεί, και το Linux ήδη έχει LRU. </a:t>
             </a:r>
             <a:pPr algn="just" indent="0" marL="0">
               <a:lnSpc>
@@ -9326,7 +9292,7 @@
                 <a:ea typeface="Times New Roman" pitchFamily="34" charset="-122"/>
                 <a:cs typeface="Times New Roman" pitchFamily="34" charset="-120"/>
               </a:rPr>
-              <a:t>Η προαγωγή είναι το ανοιχτό πρόβλημα:</a:t>
+              <a:t>Το promotion είναι το δύσκολο.</a:t>
             </a:r>
             <a:pPr algn="just" indent="0" marL="0">
               <a:lnSpc>
@@ -9343,7 +9309,7 @@
                 <a:ea typeface="Times New Roman" pitchFamily="34" charset="-122"/>
                 <a:cs typeface="Times New Roman" pitchFamily="34" charset="-120"/>
               </a:rPr>
-              <a:t> απαιτεί να γνωρίζουμε ότι μια σελίδα είναι θερμή τη δεδομένη στιγμή, και αυτό κοστίζει. Είναι θέση που διατυπώνει ρητά και η ίδια η κοινότητα του Linux MM.</a:t>
+              <a:t> Πρέπει να ξέρεις ότι ένα page είναι hot τώρα, κι αυτό κοστίζει. Το λέει και η ίδια η κοινότητα του Linux MM.</a:t>
             </a:r>
             <a:endParaRPr lang="en-US" sz="1600" dirty="0"/>
           </a:p>
@@ -9428,7 +9394,7 @@
                 <a:ea typeface="Times New Roman" pitchFamily="34" charset="-122"/>
                 <a:cs typeface="Times New Roman" pitchFamily="34" charset="-120"/>
               </a:rPr>
-              <a:t>Αστοχία: το profiling</a:t>
+              <a:t>Γιατί δεν δουλεύει: το profiling</a:t>
             </a:r>
             <a:endParaRPr lang="en-US" sz="2400" dirty="0"/>
           </a:p>
@@ -9526,7 +9492,7 @@
                 <a:ea typeface="Times New Roman" pitchFamily="34" charset="-122"/>
                 <a:cs typeface="Times New Roman" pitchFamily="34" charset="-120"/>
               </a:rPr>
-              <a:t>3. Γιατί αποτυγχάνει</a:t>
+              <a:t>3. Γιατί δεν δουλεύει</a:t>
             </a:r>
             <a:endParaRPr lang="en-US" sz="950" dirty="0"/>
           </a:p>
@@ -9618,7 +9584,7 @@
                 <a:ea typeface="Times New Roman" pitchFamily="34" charset="-122"/>
                 <a:cs typeface="Times New Roman" pitchFamily="34" charset="-120"/>
               </a:rPr>
-              <a:t>μηχανισμοί εντοπισμού θερμών σελίδων και το θεμελιώδες ελάττωμα καθενός.</a:t>
+              <a:t>τρόποι εντοπισμού των hot pages και το βασικό πρόβλημα του καθενός.</a:t>
             </a:r>
             <a:endParaRPr lang="en-US" sz="1100" dirty="0"/>
           </a:p>
@@ -9713,7 +9679,7 @@
                           <a:ea typeface="Times New Roman" pitchFamily="34" charset="-122"/>
                           <a:cs typeface="Times New Roman" pitchFamily="34" charset="-120"/>
                         </a:rPr>
-                        <a:t>Αρχή λειτουργίας</a:t>
+                        <a:t>Πώς δουλεύει</a:t>
                       </a:r>
                       <a:endParaRPr lang="en-US" sz="1350" dirty="0">
                         <a:latin typeface="Times New Roman" charset="0"/>
@@ -9757,7 +9723,7 @@
                           <a:ea typeface="Times New Roman" pitchFamily="34" charset="-122"/>
                           <a:cs typeface="Times New Roman" pitchFamily="34" charset="-120"/>
                         </a:rPr>
-                        <a:t>Θεμελιώδες ελάττωμα</a:t>
+                        <a:t>Βασικό πρόβλημα</a:t>
                       </a:r>
                       <a:endParaRPr lang="en-US" sz="1350" dirty="0">
                         <a:latin typeface="Times New Roman" charset="0"/>
@@ -9847,7 +9813,7 @@
                           <a:ea typeface="Times New Roman" pitchFamily="34" charset="-122"/>
                           <a:cs typeface="Times New Roman" pitchFamily="34" charset="-120"/>
                         </a:rPr>
-                        <a:t>Σάρωση των access bits των PTE</a:t>
+                        <a:t>Σαρώνει τα access bits των PTE</a:t>
                       </a:r>
                       <a:endParaRPr lang="en-US" sz="1350" dirty="0">
                         <a:latin typeface="Times New Roman" charset="0"/>
@@ -9891,7 +9857,7 @@
                           <a:ea typeface="Times New Roman" pitchFamily="34" charset="-122"/>
                           <a:cs typeface="Times New Roman" pitchFamily="34" charset="-120"/>
                         </a:rPr>
-                        <a:t>1 bit = δυαδική πληροφορία· η σάρωση διαρκεί δευτερόλεπτα — το θερμό σύνολο έχει ήδη αλλάξει</a:t>
+                        <a:t>1 bit = ναι/όχι. Το scan κρατάει δευτερόλεπτα, οπότε το hot set έχει ήδη αλλάξει</a:t>
                       </a:r>
                       <a:endParaRPr lang="en-US" sz="1350" dirty="0">
                         <a:latin typeface="Times New Roman" charset="0"/>
@@ -9981,7 +9947,7 @@
                           <a:ea typeface="Times New Roman" pitchFamily="34" charset="-122"/>
                           <a:cs typeface="Times New Roman" pitchFamily="34" charset="-120"/>
                         </a:rPr>
-                        <a:t>Σκόπιμη απο-χαρτογράφηση PTE ώστε η προσπέλαση να παγιδεύεται</a:t>
+                        <a:t>Κάνει unmap τα PTE ώστε το επόμενο access να πέσει σε fault</a:t>
                       </a:r>
                       <a:endParaRPr lang="en-US" sz="1350" dirty="0">
                         <a:latin typeface="Times New Roman" charset="0"/>
@@ -10025,7 +9991,7 @@
                           <a:ea typeface="Times New Roman" pitchFamily="34" charset="-122"/>
                           <a:cs typeface="Times New Roman" pitchFamily="34" charset="-120"/>
                         </a:rPr>
-                        <a:t>Μετρά αστοχίες TLB, όχι αστοχίες LLC — συσχετίζονται ασθενώς</a:t>
+                        <a:t>Μετράει TLB misses, όχι LLC misses — δεν συσχετίζονται καλά</a:t>
                       </a:r>
                       <a:endParaRPr lang="en-US" sz="1350" dirty="0">
                         <a:latin typeface="Times New Roman" charset="0"/>
@@ -10115,7 +10081,7 @@
                           <a:ea typeface="Times New Roman" pitchFamily="34" charset="-122"/>
                           <a:cs typeface="Times New Roman" pitchFamily="34" charset="-120"/>
                         </a:rPr>
-                        <a:t>Δειγματοληψία της PMU σε αστοχίες LLC</a:t>
+                        <a:t>Sampling του PMU πάνω σε LLC misses</a:t>
                       </a:r>
                       <a:endParaRPr lang="en-US" sz="1350" dirty="0">
                         <a:latin typeface="Times New Roman" charset="0"/>
@@ -10159,7 +10125,7 @@
                           <a:ea typeface="Times New Roman" pitchFamily="34" charset="-122"/>
                           <a:cs typeface="Times New Roman" pitchFamily="34" charset="-120"/>
                         </a:rPr>
-                        <a:t>Το overhead ακολουθεί τον ρυθμό δειγματοληψίας: &gt;50% επιβράδυνση σε πυκνά δείγματα</a:t>
+                        <a:t>Το overhead ανεβαίνει με το sampling rate: &gt;50% slowdown σε πυκνό sampling</a:t>
                       </a:r>
                       <a:endParaRPr lang="en-US" sz="1350" dirty="0">
                         <a:latin typeface="Times New Roman" charset="0"/>
@@ -10205,7 +10171,7 @@
                           <a:ea typeface="Courier New" pitchFamily="34" charset="-122"/>
                           <a:cs typeface="Courier New" pitchFamily="34" charset="-120"/>
                         </a:rPr>
-                        <a:t>υλικό στη συσκευή CXL</a:t>
+                        <a:t>hardware μέσα στην CXL</a:t>
                       </a:r>
                       <a:endParaRPr lang="en-US" sz="1150" dirty="0">
                         <a:latin typeface="Courier New" charset="0"/>
@@ -10249,7 +10215,7 @@
                           <a:ea typeface="Times New Roman" pitchFamily="34" charset="-122"/>
                           <a:cs typeface="Times New Roman" pitchFamily="34" charset="-120"/>
                         </a:rPr>
-                        <a:t>Μετρητές μέσα στον ελεγκτή της συσκευής</a:t>
+                        <a:t>Counters μέσα στον controller της συσκευής</a:t>
                       </a:r>
                       <a:endParaRPr lang="en-US" sz="1350" dirty="0">
                         <a:latin typeface="Times New Roman" charset="0"/>
@@ -10293,7 +10259,7 @@
                           <a:ea typeface="Times New Roman" pitchFamily="34" charset="-122"/>
                           <a:cs typeface="Times New Roman" pitchFamily="34" charset="-120"/>
                         </a:rPr>
-                        <a:t>Σωστό γεγονός, μηδενικό κόστος CPU — αλλά απαιτεί νέο υλικό</a:t>
+                        <a:t>Σωστό event, μηδέν κόστος CPU — αλλά θέλει καινούριο hardware</a:t>
                       </a:r>
                       <a:endParaRPr lang="en-US" sz="1350" dirty="0">
                         <a:latin typeface="Times New Roman" charset="0"/>
@@ -10421,7 +10387,7 @@
                 <a:ea typeface="Times New Roman" pitchFamily="34" charset="-122"/>
                 <a:cs typeface="Times New Roman" pitchFamily="34" charset="-120"/>
               </a:rPr>
-              <a:t>Το κρίσιμο σημείο. </a:t>
+              <a:t>Το σημαντικό. </a:t>
             </a:r>
             <a:pPr algn="just" indent="0" marL="0">
               <a:lnSpc>
@@ -10438,7 +10404,7 @@
                 <a:ea typeface="Times New Roman" pitchFamily="34" charset="-122"/>
                 <a:cs typeface="Times New Roman" pitchFamily="34" charset="-120"/>
               </a:rPr>
-              <a:t>Οι AutoNUMA και TPP μετρούν αστοχίες TLB, αλλά την κίνηση προς τη μνήμη CXL την καθορίζουν οι αστοχίες LLC· μια σελίδα μπορεί να είναι έντονα θερμή ως προς το TLB και σχεδόν αόρατη ως προς την κίνηση CXL. Βελτιστοποιούν, δηλαδή, το λάθος σήμα.</a:t>
+              <a:t>AutoNUMA και TPP μετράνε TLB misses, αλλά το traffic προς την CXL το καθορίζουν τα LLC misses. Ένα page μπορεί να είναι πολύ hot στο TLB και σχεδόν αόρατο στην CXL. Δηλαδή βελτιστοποιούν το λάθος σήμα.</a:t>
             </a:r>
             <a:endParaRPr lang="en-US" sz="1500" dirty="0"/>
           </a:p>
@@ -10523,7 +10489,7 @@
                 <a:ea typeface="Times New Roman" pitchFamily="34" charset="-122"/>
                 <a:cs typeface="Times New Roman" pitchFamily="34" charset="-120"/>
               </a:rPr>
-              <a:t>Αστοχία: η κοκκομέτρηση</a:t>
+              <a:t>Γιατί δεν δουλεύει: το granularity</a:t>
             </a:r>
             <a:endParaRPr lang="en-US" sz="2400" dirty="0"/>
           </a:p>
@@ -10621,7 +10587,7 @@
                 <a:ea typeface="Times New Roman" pitchFamily="34" charset="-122"/>
                 <a:cs typeface="Times New Roman" pitchFamily="34" charset="-120"/>
               </a:rPr>
-              <a:t>3. Γιατί αποτυγχάνει</a:t>
+              <a:t>3. Γιατί δεν δουλεύει</a:t>
             </a:r>
             <a:endParaRPr lang="en-US" sz="950" dirty="0"/>
           </a:p>
@@ -10702,7 +10668,7 @@
                 <a:ea typeface="Times New Roman" pitchFamily="34" charset="-122"/>
                 <a:cs typeface="Times New Roman" pitchFamily="34" charset="-120"/>
               </a:rPr>
-              <a:t>Η πυκνότητα των προσπελάσεων μέσα σε μια σελίδα 4 KB είναι εξαιρετικά ανομοιόμορφη: μια αναζήτηση σε πίνακα κατακερματισμού αγγίζει 64 bytes από τα 4096 (βλ. Σχήμα 2). Το 4 KB είναι λάθος μονάδα και προς τις δύο κατευθύνσεις — υπερβολικά χονδρό για ό,τι είναι πραγματικά θερμό, αλλά και υπερβολικά λεπτό για τον μηχανισμό μετανάστευσης, που πληρώνει σταθερό κόστος ανά σελίδα.</a:t>
+              <a:t>Μέσα σε ένα page 4 KB, τα accesses δεν είναι μοιρασμένα ομοιόμορφα. Ένα lookup σε hash table αγγίζει 64 bytes από τα 4096 (Σχήμα 2). Το 4 KB είναι λάθος unit και προς τις δύο μεριές: πολύ μεγάλο για το τι είναι πραγματικά hot, αλλά και πολύ μικρό για τον μηχανισμό του migration, που πληρώνει σταθερό κόστος ανά page.</a:t>
             </a:r>
             <a:endParaRPr lang="en-US" sz="1550" dirty="0"/>
           </a:p>
@@ -10822,7 +10788,7 @@
                 <a:ea typeface="Times New Roman" pitchFamily="34" charset="-122"/>
                 <a:cs typeface="Times New Roman" pitchFamily="34" charset="-120"/>
               </a:rPr>
-              <a:t>ελάχιστη σπατάλη· μη διαχειρίσιμα μεταδεδομένα</a:t>
+              <a:t>ελάχιστο waste· τα metadata εκτοξεύονται</a:t>
             </a:r>
             <a:endParaRPr lang="en-US" sz="1250" dirty="0"/>
           </a:p>
@@ -10939,7 +10905,7 @@
                 <a:ea typeface="Courier New" pitchFamily="34" charset="-122"/>
                 <a:cs typeface="Courier New" pitchFamily="34" charset="-120"/>
               </a:rPr>
-              <a:t>προεπιλογή Linux</a:t>
+              <a:t>default του Linux</a:t>
             </a:r>
             <a:endParaRPr lang="en-US" sz="1100" dirty="0"/>
           </a:p>
@@ -10981,7 +10947,7 @@
                 <a:ea typeface="Times New Roman" pitchFamily="34" charset="-122"/>
                 <a:cs typeface="Times New Roman" pitchFamily="34" charset="-120"/>
               </a:rPr>
-              <a:t>μέτριο και στα δύο: σπαταλά και κοστίζει</a:t>
+              <a:t>μέτριο και στα δύο: κάνει waste και κοστίζει</a:t>
             </a:r>
             <a:endParaRPr lang="en-US" sz="1250" dirty="0"/>
           </a:p>
@@ -11140,7 +11106,7 @@
                 <a:ea typeface="Times New Roman" pitchFamily="34" charset="-122"/>
                 <a:cs typeface="Times New Roman" pitchFamily="34" charset="-120"/>
               </a:rPr>
-              <a:t>φθηνή μετανάστευση· τεράστια σπατάλη (&gt;99%)</a:t>
+              <a:t>φθηνό migration· τεράστιο waste (&gt;99%)</a:t>
             </a:r>
             <a:endParaRPr lang="en-US" sz="1250" dirty="0"/>
           </a:p>
@@ -11193,7 +11159,7 @@
                 <a:ea typeface="Times New Roman" pitchFamily="34" charset="-122"/>
                 <a:cs typeface="Times New Roman" pitchFamily="34" charset="-120"/>
               </a:rPr>
-              <a:t>το φάσμα κοκκομέτρησης — καμία επιλογή δεν είναι καλή ταυτόχρονα σε σπατάλη και σε κόστος.</a:t>
+              <a:t>το φάσμα του granularity — καμία επιλογή δεν είναι καλή και στα δύο ταυτόχρονα.</a:t>
             </a:r>
             <a:endParaRPr lang="en-US" sz="1100" dirty="0"/>
           </a:p>
@@ -11252,7 +11218,7 @@
                 <a:ea typeface="Times New Roman" pitchFamily="34" charset="-122"/>
                 <a:cs typeface="Times New Roman" pitchFamily="34" charset="-120"/>
               </a:rPr>
-              <a:t>Κρίσιμο σημείο — δεν υπάρχει PTE για μια cache line</a:t>
+              <a:t>Το ουσιαστικό — δεν υπάρχει PTE για cache line</a:t>
             </a:r>
             <a:endParaRPr lang="en-US" sz="1450" dirty="0"/>
           </a:p>
@@ -11294,7 +11260,7 @@
                 <a:ea typeface="Times New Roman" pitchFamily="34" charset="-122"/>
                 <a:cs typeface="Times New Roman" pitchFamily="34" charset="-120"/>
               </a:rPr>
-              <a:t>Άρα κανείς δεν μπορεί να «μεταναστεύσει γραμμές αντί για σελίδες» μέσα από το λειτουργικό. Η λύση είναι είτε έμμεση αναφορά σε υλικό (η τοπική DRAM γίνεται κρυφή μνήμη γραμμών), είτε — και εδώ στοχεύει η εργασία — profiling σε λεπτή κοκκομέτρηση (64 B) που οδηγεί αποφάσεις μετανάστευσης σε χονδρή (4 KB). Η κοκκομέτρηση profiling διαφέρει από την κοκκομέτρηση migration· αυτό ακριβώς κάνει το M5.</a:t>
+              <a:t>Άρα δεν γίνεται να κάνεις migrate cache lines αντί για pages μέσα από το OS. Ή βάζεις hardware indirection (η τοπική DRAM γίνεται cache γραμμών), ή —κι εδώ στοχεύω— κάνεις profiling σε λεπτό granularity (64 B) και migration σε χοντρό (4 KB). Το granularity του profiling δεν είναι ίδιο με του migration· αυτό ακριβώς κάνει το M5.</a:t>
             </a:r>
             <a:endParaRPr lang="en-US" sz="1350" dirty="0"/>
           </a:p>
@@ -11379,7 +11345,7 @@
                 <a:ea typeface="Times New Roman" pitchFamily="34" charset="-122"/>
                 <a:cs typeface="Times New Roman" pitchFamily="34" charset="-120"/>
               </a:rPr>
-              <a:t>Αστοχία: το κόστος μεταφοράς</a:t>
+              <a:t>Γιατί δεν δουλεύει: το κόστος του migration</a:t>
             </a:r>
             <a:endParaRPr lang="en-US" sz="2400" dirty="0"/>
           </a:p>
@@ -11477,7 +11443,7 @@
                 <a:ea typeface="Times New Roman" pitchFamily="34" charset="-122"/>
                 <a:cs typeface="Times New Roman" pitchFamily="34" charset="-120"/>
               </a:rPr>
-              <a:t>3. Γιατί αποτυγχάνει</a:t>
+              <a:t>3. Γιατί δεν δουλεύει</a:t>
             </a:r>
             <a:endParaRPr lang="en-US" sz="950" dirty="0"/>
           </a:p>
@@ -11555,7 +11521,7 @@
                 <a:ea typeface="Times New Roman" pitchFamily="34" charset="-122"/>
                 <a:cs typeface="Times New Roman" pitchFamily="34" charset="-120"/>
               </a:rPr>
-              <a:t>Για να προαχθεί μία σελίδα 4 KB, ο πυρήνας πληρώνει τέσσερα κόστη:</a:t>
+              <a:t>Για να προαχθεί ένα page 4 KB, το OS πληρώνει τέσσερα κόστη:</a:t>
             </a:r>
             <a:endParaRPr lang="en-US" sz="1600" dirty="0"/>
           </a:p>
@@ -11579,7 +11545,7 @@
           <a:ln/>
         </p:spPr>
         <p:txBody>
-          <a:bodyPr wrap="square" lIns="0" tIns="0" rIns="0" bIns="0" rtlCol="0" anchor="ctr"/>
+          <a:bodyPr wrap="square" lIns="0" tIns="0" rIns="0" bIns="0" rtlCol="0" anchor="t"/>
           <a:lstStyle/>
           <a:p>
             <a:pPr indent="0" marL="0">
@@ -11618,7 +11584,7 @@
           <a:ln/>
         </p:spPr>
         <p:txBody>
-          <a:bodyPr wrap="square" lIns="0" tIns="0" rIns="0" bIns="0" rtlCol="0" anchor="ctr"/>
+          <a:bodyPr wrap="square" lIns="0" tIns="0" rIns="0" bIns="0" rtlCol="0" anchor="t"/>
           <a:lstStyle/>
           <a:p>
             <a:pPr algn="just" indent="0" marL="0">
@@ -11636,7 +11602,7 @@
                 <a:ea typeface="Times New Roman" pitchFamily="34" charset="-122"/>
                 <a:cs typeface="Times New Roman" pitchFamily="34" charset="-120"/>
               </a:rPr>
-              <a:t>Αντιγραφή. </a:t>
+              <a:t>Copy. </a:t>
             </a:r>
             <a:pPr algn="just" indent="0" marL="0">
               <a:lnSpc>
@@ -11653,7 +11619,7 @@
                 <a:ea typeface="Times New Roman" pitchFamily="34" charset="-122"/>
                 <a:cs typeface="Times New Roman" pitchFamily="34" charset="-120"/>
               </a:rPr>
-              <a:t>4 KB ανάγνωση από CXL και 4 KB εγγραφή σε DDR — καταναλώνει το εύρος ζώνης που θέλει να σώσει.</a:t>
+              <a:t>4 KB read από CXL + 4 KB write σε DDR — τρώει το bandwidth που θέλεις να γλιτώσεις.</a:t>
             </a:r>
             <a:endParaRPr lang="en-US" sz="1350" dirty="0"/>
           </a:p>
@@ -11677,7 +11643,7 @@
           <a:ln/>
         </p:spPr>
         <p:txBody>
-          <a:bodyPr wrap="square" lIns="0" tIns="0" rIns="0" bIns="0" rtlCol="0" anchor="ctr"/>
+          <a:bodyPr wrap="square" lIns="0" tIns="0" rIns="0" bIns="0" rtlCol="0" anchor="t"/>
           <a:lstStyle/>
           <a:p>
             <a:pPr indent="0" marL="0">
@@ -11716,7 +11682,7 @@
           <a:ln/>
         </p:spPr>
         <p:txBody>
-          <a:bodyPr wrap="square" lIns="0" tIns="0" rIns="0" bIns="0" rtlCol="0" anchor="ctr"/>
+          <a:bodyPr wrap="square" lIns="0" tIns="0" rIns="0" bIns="0" rtlCol="0" anchor="t"/>
           <a:lstStyle/>
           <a:p>
             <a:pPr algn="just" indent="0" marL="0">
@@ -11734,7 +11700,7 @@
                 <a:ea typeface="Times New Roman" pitchFamily="34" charset="-122"/>
                 <a:cs typeface="Times New Roman" pitchFamily="34" charset="-120"/>
               </a:rPr>
-              <a:t>Ενημέρωση πίνακα σελίδων. </a:t>
+              <a:t>Ενημέρωση page table. </a:t>
             </a:r>
             <a:pPr algn="just" indent="0" marL="0">
               <a:lnSpc>
@@ -11751,7 +11717,7 @@
                 <a:ea typeface="Times New Roman" pitchFamily="34" charset="-122"/>
                 <a:cs typeface="Times New Roman" pitchFamily="34" charset="-120"/>
               </a:rPr>
-              <a:t>Διάσχιση του rmap για κάθε PTE που χαρτογραφεί τη σελίδα.</a:t>
+              <a:t>Διάσχιση του rmap για κάθε PTE που δείχνει στο page.</a:t>
             </a:r>
             <a:endParaRPr lang="en-US" sz="1350" dirty="0"/>
           </a:p>
@@ -11775,7 +11741,7 @@
           <a:ln/>
         </p:spPr>
         <p:txBody>
-          <a:bodyPr wrap="square" lIns="0" tIns="0" rIns="0" bIns="0" rtlCol="0" anchor="ctr"/>
+          <a:bodyPr wrap="square" lIns="0" tIns="0" rIns="0" bIns="0" rtlCol="0" anchor="t"/>
           <a:lstStyle/>
           <a:p>
             <a:pPr indent="0" marL="0">
@@ -11814,7 +11780,7 @@
           <a:ln/>
         </p:spPr>
         <p:txBody>
-          <a:bodyPr wrap="square" lIns="0" tIns="0" rIns="0" bIns="0" rtlCol="0" anchor="ctr"/>
+          <a:bodyPr wrap="square" lIns="0" tIns="0" rIns="0" bIns="0" rtlCol="0" anchor="t"/>
           <a:lstStyle/>
           <a:p>
             <a:pPr algn="just" indent="0" marL="0">
@@ -11832,7 +11798,7 @@
                 <a:ea typeface="Times New Roman" pitchFamily="34" charset="-122"/>
                 <a:cs typeface="Times New Roman" pitchFamily="34" charset="-120"/>
               </a:rPr>
-              <a:t>Ακύρωση TLB (shootdown). </a:t>
+              <a:t>TLB shootdown. </a:t>
             </a:r>
             <a:pPr algn="just" indent="0" marL="0">
               <a:lnSpc>
@@ -11849,7 +11815,7 @@
                 <a:ea typeface="Times New Roman" pitchFamily="34" charset="-122"/>
                 <a:cs typeface="Times New Roman" pitchFamily="34" charset="-120"/>
               </a:rPr>
-              <a:t>IPI προς κάθε πυρήνα με πιθανή cached μετάφραση — συνήθως το κυρίαρχο κόστος.</a:t>
+              <a:t>IPI σε κάθε core με πιθανό cached translation — συνήθως το πιο ακριβό.</a:t>
             </a:r>
             <a:endParaRPr lang="en-US" sz="1350" dirty="0"/>
           </a:p>
@@ -11873,7 +11839,7 @@
           <a:ln/>
         </p:spPr>
         <p:txBody>
-          <a:bodyPr wrap="square" lIns="0" tIns="0" rIns="0" bIns="0" rtlCol="0" anchor="ctr"/>
+          <a:bodyPr wrap="square" lIns="0" tIns="0" rIns="0" bIns="0" rtlCol="0" anchor="t"/>
           <a:lstStyle/>
           <a:p>
             <a:pPr indent="0" marL="0">
@@ -11912,7 +11878,7 @@
           <a:ln/>
         </p:spPr>
         <p:txBody>
-          <a:bodyPr wrap="square" lIns="0" tIns="0" rIns="0" bIns="0" rtlCol="0" anchor="ctr"/>
+          <a:bodyPr wrap="square" lIns="0" tIns="0" rIns="0" bIns="0" rtlCol="0" anchor="t"/>
           <a:lstStyle/>
           <a:p>
             <a:pPr algn="just" indent="0" marL="0">
@@ -11930,7 +11896,7 @@
                 <a:ea typeface="Times New Roman" pitchFamily="34" charset="-122"/>
                 <a:cs typeface="Times New Roman" pitchFamily="34" charset="-120"/>
               </a:rPr>
-              <a:t>Ανταγωνισμός κλειδωμάτων. </a:t>
+              <a:t>Lock contention. </a:t>
             </a:r>
             <a:pPr algn="just" indent="0" marL="0">
               <a:lnSpc>
@@ -11947,7 +11913,7 @@
                 <a:ea typeface="Times New Roman" pitchFamily="34" charset="-122"/>
                 <a:cs typeface="Times New Roman" pitchFamily="34" charset="-120"/>
               </a:rPr>
-              <a:t>mmap_lock, LRU locks· δεν παραλληλοποιείται καλά.</a:t>
+              <a:t>mmap_lock, LRU locks· δεν κάνει καλό scaling.</a:t>
             </a:r>
             <a:endParaRPr lang="en-US" sz="1350" dirty="0"/>
           </a:p>
@@ -12048,7 +12014,7 @@
                 <a:ea typeface="Times New Roman" pitchFamily="34" charset="-122"/>
                 <a:cs typeface="Times New Roman" pitchFamily="34" charset="-120"/>
               </a:rPr>
-              <a:t>Μια μετανάστευση σελίδας κοστίζει της τάξης των μικροδευτερολέπτων (μs) — χιλιάδες φορές περισσότερο από τα ~250 ns που προσπαθούμε να αποφύγουμε ανά προσπέλαση.</a:t>
+              <a:t>Ένα migration ενός page κοστίζει μsec — χιλιάδες φορές πάνω από τα ~250 ns που προσπαθείς να αποφύγεις ανά access.</a:t>
             </a:r>
             <a:endParaRPr lang="en-US" sz="1350" dirty="0"/>
           </a:p>
@@ -12077,7 +12043,7 @@
                 <a:ea typeface="Times New Roman" pitchFamily="34" charset="-122"/>
                 <a:cs typeface="Times New Roman" pitchFamily="34" charset="-120"/>
               </a:rPr>
-              <a:t>Συνέπεια: μια σελίδα πρέπει να ξαναπροσπελαστεί πολλές φορές για να αποσβέσει τη μεταφορά της. Γι’ αυτό μια λανθασμένη προαγωγή δεν είναι απλώς άχρηστη — είναι ενεργά επιζήμια.</a:t>
+              <a:t>Άρα ένα page πρέπει να ξαναχρησιμοποιηθεί πολλές φορές για να αξίζει το migration. Γι’ αυτό ένα λάθος promotion δεν είναι απλώς άχρηστο· είναι και επιζήμιο.</a:t>
             </a:r>
             <a:endParaRPr lang="en-US" sz="1350" dirty="0"/>
           </a:p>
@@ -12119,7 +12085,7 @@
                 <a:ea typeface="Times New Roman" pitchFamily="34" charset="-122"/>
                 <a:cs typeface="Times New Roman" pitchFamily="34" charset="-120"/>
               </a:rPr>
-              <a:t>Το κόστος αυτό είναι που επιβάλλει ποσόστωση (quota) στο εύρος ζώνης μετανάστευσης και υστέρηση (hysteresis) στις αποφάσεις — ώστε ο μηχανισμός να μην καταναλώνει τους πόρους που υποτίθεται ότι σώζει.</a:t>
+              <a:t>Αυτό το κόστος είναι που επιβάλλει quota στο migration bandwidth και hysteresis στις αποφάσεις, ώστε ο μηχανισμός να μην καίει τους πόρους που υποτίθεται ότι γλιτώνει.</a:t>
             </a:r>
             <a:endParaRPr lang="en-US" sz="1450" dirty="0"/>
           </a:p>
@@ -12204,7 +12170,7 @@
                 <a:ea typeface="Times New Roman" pitchFamily="34" charset="-122"/>
                 <a:cs typeface="Times New Roman" pitchFamily="34" charset="-120"/>
               </a:rPr>
-              <a:t>Τρεις εργασίες, τρεις διαγνώσεις</a:t>
+              <a:t>Τρεις εργασίες, τρεις διαφορετικές διαγνώσεις</a:t>
             </a:r>
             <a:endParaRPr lang="en-US" sz="2400" dirty="0"/>
           </a:p>
@@ -12302,7 +12268,7 @@
                 <a:ea typeface="Times New Roman" pitchFamily="34" charset="-122"/>
                 <a:cs typeface="Times New Roman" pitchFamily="34" charset="-120"/>
               </a:rPr>
-              <a:t>4. Σχετική βιβλιογραφία</a:t>
+              <a:t>4. Σχετικές εργασίες</a:t>
             </a:r>
             <a:endParaRPr lang="en-US" sz="950" dirty="0"/>
           </a:p>
@@ -12394,7 +12360,7 @@
                 <a:ea typeface="Times New Roman" pitchFamily="34" charset="-122"/>
                 <a:cs typeface="Times New Roman" pitchFamily="34" charset="-120"/>
               </a:rPr>
-              <a:t>οι τρεις εργασίες αναφοράς εντοπίζουν διαφορετική ρίζα του ίδιου προβλήματος.</a:t>
+              <a:t>και οι τρεις δείχνουν διαφορετική ρίζα για το ίδιο πρόβλημα.</a:t>
             </a:r>
             <a:endParaRPr lang="en-US" sz="1100" dirty="0"/>
           </a:p>
@@ -12578,7 +12544,7 @@
                           <a:ea typeface="Times New Roman" pitchFamily="34" charset="-122"/>
                           <a:cs typeface="Times New Roman" pitchFamily="34" charset="-120"/>
                         </a:rPr>
-                        <a:t>Κοκκομέτρηση</a:t>
+                        <a:t>Granularity</a:t>
                       </a:r>
                       <a:endParaRPr lang="en-US" sz="1350" dirty="0">
                         <a:latin typeface="Times New Roman" charset="0"/>
@@ -12689,7 +12655,7 @@
                           <a:ea typeface="Times New Roman" pitchFamily="34" charset="-122"/>
                           <a:cs typeface="Times New Roman" pitchFamily="34" charset="-120"/>
                         </a:rPr>
-                        <a:t>Το profiling είναι αργό και χονδροειδές — διορθώνοντάς το, οι σελίδες 4 KB αρκούν</a:t>
+                        <a:t>Το profiling είναι αργό και χοντρό — φτιάξ’ το και τα 4 KB pages φτάνουν</a:t>
                       </a:r>
                       <a:endParaRPr lang="en-US" sz="1350" dirty="0">
                         <a:latin typeface="Times New Roman" charset="0"/>
@@ -12733,7 +12699,7 @@
                           <a:ea typeface="Times New Roman" pitchFamily="34" charset="-122"/>
                           <a:cs typeface="Times New Roman" pitchFamily="34" charset="-120"/>
                         </a:rPr>
-                        <a:t>Count-min sketch μέσα στον ελεγκτή CXL και δυναμικό κατώφλι θερμότητας</a:t>
+                        <a:t>Count-min sketch μέσα στον CXL controller + dynamic hotness threshold</a:t>
                       </a:r>
                       <a:endParaRPr lang="en-US" sz="1350" dirty="0">
                         <a:latin typeface="Times New Roman" charset="0"/>
@@ -12888,7 +12854,7 @@
                           <a:ea typeface="Times New Roman" pitchFamily="34" charset="-122"/>
                           <a:cs typeface="Times New Roman" pitchFamily="34" charset="-120"/>
                         </a:rPr>
-                        <a:t>Η θερμότητα είναι υπο-σελιδική — το πλήθος προσπελάσεων ανά σελίδα παραπλανά</a:t>
+                        <a:t>Το hotness είναι sub-page — το πλήθος των accesses ανά page σε ξεγελάει</a:t>
                       </a:r>
                       <a:endParaRPr lang="en-US" sz="1350" dirty="0">
                         <a:latin typeface="Times New Roman" charset="0"/>
@@ -12932,7 +12898,7 @@
                           <a:ea typeface="Times New Roman" pitchFamily="34" charset="-122"/>
                           <a:cs typeface="Times New Roman" pitchFamily="34" charset="-120"/>
                         </a:rPr>
-                        <a:t>Top-K trackers για σελίδες (HPT) και για λέξεις 64 B (HWT)</a:t>
+                        <a:t>Top-K trackers για pages (HPT) και για 64 B words (HWT)</a:t>
                       </a:r>
                       <a:endParaRPr lang="en-US" sz="1350" dirty="0">
                         <a:latin typeface="Times New Roman" charset="0"/>
@@ -13108,7 +13074,7 @@
                           <a:ea typeface="Times New Roman" pitchFamily="34" charset="-122"/>
                           <a:cs typeface="Times New Roman" pitchFamily="34" charset="-120"/>
                         </a:rPr>
-                        <a:t>Το tiering σε υλικό λειτουργεί — έως ότου συνυπάρξουν πολλές VM και συγκρουστούν</a:t>
+                        <a:t>Το hardware tiering δουλεύει — μέχρι να μπουν πολλές VMs και να συγκρουστούν</a:t>
                       </a:r>
                       <a:endParaRPr lang="en-US" sz="1350" dirty="0">
                         <a:latin typeface="Times New Roman" charset="0"/>
@@ -13152,7 +13118,7 @@
                           <a:ea typeface="Times New Roman" pitchFamily="34" charset="-122"/>
                           <a:cs typeface="Times New Roman" pitchFamily="34" charset="-120"/>
                         </a:rPr>
-                        <a:t>Χρωματισμός σελίδων και online εκτιμητής επιβράδυνσης</a:t>
+                        <a:t>Page coloring + online slowdown estimator</a:t>
                       </a:r>
                       <a:endParaRPr lang="en-US" sz="1350" dirty="0">
                         <a:latin typeface="Times New Roman" charset="0"/>
@@ -13188,7 +13154,7 @@
                         <a:buNone/>
                       </a:pPr>
                       <a:r>
-                        <a:rPr lang="en-US" sz="1200" dirty="0">
+                        <a:rPr lang="en-US" sz="1150" dirty="0">
                           <a:solidFill>
                             <a:srgbClr val="1A1A1A"/>
                           </a:solidFill>
@@ -13196,9 +13162,9 @@
                           <a:ea typeface="Courier New" pitchFamily="34" charset="-122"/>
                           <a:cs typeface="Courier New" pitchFamily="34" charset="-120"/>
                         </a:rPr>
-                        <a:t>64 B (υλικό)</a:t>
+                        <a:t>64 B (hardware)</a:t>
                       </a:r>
-                      <a:endParaRPr lang="en-US" sz="1200" dirty="0">
+                      <a:endParaRPr lang="en-US" sz="1150" dirty="0">
                         <a:latin typeface="Courier New" charset="0"/>
                         <a:ea typeface="Courier New" charset="0"/>
                         <a:cs typeface="Courier New" charset="0"/>
@@ -13324,7 +13290,7 @@
                 <a:ea typeface="Times New Roman" pitchFamily="34" charset="-122"/>
                 <a:cs typeface="Times New Roman" pitchFamily="34" charset="-120"/>
               </a:rPr>
-              <a:t>Οι τρεις διαγνώσεις διαφωνούν, και αυτό είναι διαφωτιστικό: </a:t>
+              <a:t>Οι τρεις διαγνώσεις διαφωνούν, και αυτό βοηθάει: </a:t>
             </a:r>
             <a:pPr algn="just" indent="0" marL="0">
               <a:lnSpc>
@@ -13341,7 +13307,7 @@
                 <a:ea typeface="Times New Roman" pitchFamily="34" charset="-122"/>
                 <a:cs typeface="Times New Roman" pitchFamily="34" charset="-120"/>
               </a:rPr>
-              <a:t>το NeoMem εντοπίζει έλλειψη ανάλυσης στον χρόνο, το M5 έλλειψη ανάλυσης στον χώρο, ενώ το Memstrata δείχνει ότι το πρόβλημα εκδηλώνεται μόνο υπό συστέγαση πολλών φόρτων. Η εργασία εστιάζει στο M5, ως το πλησιέστερο στην υπόθεση της υπο-σελιδικής θερμότητας.</a:t>
+              <a:t>το NeoMem λέει ότι λείπει resolution στον χρόνο, το M5 ότι λείπει στον χώρο, και το Memstrata ότι το πρόβλημα βγαίνει μόνο όταν συνυπάρχουν πολλά workloads. Διαλέγω το M5, γιατί είναι πιο κοντά στην ιδέα του sub-page hotness.</a:t>
             </a:r>
             <a:endParaRPr lang="en-US" sz="1500" dirty="0"/>
           </a:p>
@@ -13426,7 +13392,7 @@
                 <a:ea typeface="Times New Roman" pitchFamily="34" charset="-122"/>
                 <a:cs typeface="Times New Roman" pitchFamily="34" charset="-120"/>
               </a:rPr>
-              <a:t>Ο έντιμος συμβιβασμός: σελίδες ή γραμμές;</a:t>
+              <a:t>Ο τίμιος συμβιβασμός: pages ή lines;</a:t>
             </a:r>
             <a:endParaRPr lang="en-US" sz="2400" dirty="0"/>
           </a:p>
@@ -13524,7 +13490,7 @@
                 <a:ea typeface="Times New Roman" pitchFamily="34" charset="-122"/>
                 <a:cs typeface="Times New Roman" pitchFamily="34" charset="-120"/>
               </a:rPr>
-              <a:t>4. Σχετική βιβλιογραφία</a:t>
+              <a:t>4. Σχετικές εργασίες</a:t>
             </a:r>
             <a:endParaRPr lang="en-US" sz="950" dirty="0"/>
           </a:p>
@@ -13616,7 +13582,7 @@
                 <a:ea typeface="Times New Roman" pitchFamily="34" charset="-122"/>
                 <a:cs typeface="Times New Roman" pitchFamily="34" charset="-120"/>
               </a:rPr>
-              <a:t>σύγκριση μετανάστευσης σελίδων (λογισμικό) και caching γραμμών (υλικό).</a:t>
+              <a:t>page migration (software) vs line caching (hardware).</a:t>
             </a:r>
             <a:endParaRPr lang="en-US" sz="1100" dirty="0"/>
           </a:p>
@@ -13711,7 +13677,7 @@
                           <a:ea typeface="Times New Roman" pitchFamily="34" charset="-122"/>
                           <a:cs typeface="Times New Roman" pitchFamily="34" charset="-120"/>
                         </a:rPr>
-                        <a:t>Μετανάστευση σελίδων (OS)</a:t>
+                        <a:t>Page migration (OS)</a:t>
                       </a:r>
                       <a:endParaRPr lang="en-US" sz="1300" dirty="0">
                         <a:latin typeface="Times New Roman" charset="0"/>
@@ -13755,7 +13721,7 @@
                           <a:ea typeface="Times New Roman" pitchFamily="34" charset="-122"/>
                           <a:cs typeface="Times New Roman" pitchFamily="34" charset="-120"/>
                         </a:rPr>
-                        <a:t>Caching γραμμών (υλικό)</a:t>
+                        <a:t>Line caching (hardware)</a:t>
                       </a:r>
                       <a:endParaRPr lang="en-US" sz="1300" dirty="0">
                         <a:latin typeface="Times New Roman" charset="0"/>
@@ -13801,7 +13767,7 @@
                           <a:ea typeface="Times New Roman" pitchFamily="34" charset="-122"/>
                           <a:cs typeface="Times New Roman" pitchFamily="34" charset="-120"/>
                         </a:rPr>
-                        <a:t>Μονάδα</a:t>
+                        <a:t>Unit</a:t>
                       </a:r>
                       <a:endParaRPr lang="en-US" sz="1300" dirty="0">
                         <a:latin typeface="Times New Roman" charset="0"/>
@@ -13979,7 +13945,7 @@
                           <a:ea typeface="Times New Roman" pitchFamily="34" charset="-122"/>
                           <a:cs typeface="Times New Roman" pitchFamily="34" charset="-120"/>
                         </a:rPr>
-                        <a:t>OS, με παρωχημένη πληροφορία</a:t>
+                        <a:t>το OS, με παλιά πληροφορία</a:t>
                       </a:r>
                       <a:endParaRPr lang="en-US" sz="1300" dirty="0">
                         <a:latin typeface="Times New Roman" charset="0"/>
@@ -14023,7 +13989,7 @@
                           <a:ea typeface="Times New Roman" pitchFamily="34" charset="-122"/>
                           <a:cs typeface="Times New Roman" pitchFamily="34" charset="-120"/>
                         </a:rPr>
-                        <a:t>Υλικό, αντιδραστικά</a:t>
+                        <a:t>το hardware, reactively</a:t>
                       </a:r>
                       <a:endParaRPr lang="en-US" sz="1300" dirty="0">
                         <a:latin typeface="Times New Roman" charset="0"/>
@@ -14069,7 +14035,7 @@
                           <a:ea typeface="Times New Roman" pitchFamily="34" charset="-122"/>
                           <a:cs typeface="Times New Roman" pitchFamily="34" charset="-120"/>
                         </a:rPr>
-                        <a:t>Χαμένη μεταφορά</a:t>
+                        <a:t>Waste στο transfer</a:t>
                       </a:r>
                       <a:endParaRPr lang="en-US" sz="1300" dirty="0">
                         <a:latin typeface="Times New Roman" charset="0"/>
@@ -14113,7 +14079,7 @@
                           <a:ea typeface="Times New Roman" pitchFamily="34" charset="-122"/>
                           <a:cs typeface="Times New Roman" pitchFamily="34" charset="-120"/>
                         </a:rPr>
-                        <a:t>Υψηλή</a:t>
+                        <a:t>Μεγάλο</a:t>
                       </a:r>
                       <a:endParaRPr lang="en-US" sz="1300" dirty="0">
                         <a:latin typeface="Times New Roman" charset="0"/>
@@ -14157,7 +14123,7 @@
                           <a:ea typeface="Times New Roman" pitchFamily="34" charset="-122"/>
                           <a:cs typeface="Times New Roman" pitchFamily="34" charset="-120"/>
                         </a:rPr>
-                        <a:t>Σχεδόν μηδενική</a:t>
+                        <a:t>Σχεδόν μηδέν</a:t>
                       </a:r>
                       <a:endParaRPr lang="en-US" sz="1300" dirty="0">
                         <a:latin typeface="Times New Roman" charset="0"/>
@@ -14337,7 +14303,7 @@
                           <a:ea typeface="Times New Roman" pitchFamily="34" charset="-122"/>
                           <a:cs typeface="Times New Roman" pitchFamily="34" charset="-120"/>
                         </a:rPr>
-                        <a:t>Μεταδεδομένα</a:t>
+                        <a:t>Metadata</a:t>
                       </a:r>
                       <a:endParaRPr lang="en-US" sz="1300" dirty="0">
                         <a:latin typeface="Times New Roman" charset="0"/>
@@ -14381,7 +14347,7 @@
                           <a:ea typeface="Times New Roman" pitchFamily="34" charset="-122"/>
                           <a:cs typeface="Times New Roman" pitchFamily="34" charset="-120"/>
                         </a:rPr>
-                        <a:t>Πίνακες σελίδων (ήδη υπάρχουν)</a:t>
+                        <a:t>page tables (υπάρχουν ήδη)</a:t>
                       </a:r>
                       <a:endParaRPr lang="en-US" sz="1300" dirty="0">
                         <a:latin typeface="Times New Roman" charset="0"/>
@@ -14425,7 +14391,7 @@
                           <a:ea typeface="Times New Roman" pitchFamily="34" charset="-122"/>
                           <a:cs typeface="Times New Roman" pitchFamily="34" charset="-120"/>
                         </a:rPr>
-                        <a:t>Πίνακας ετικετών — τεράστιος</a:t>
+                        <a:t>tag array — τεράστιο</a:t>
                       </a:r>
                       <a:endParaRPr lang="en-US" sz="1300" dirty="0">
                         <a:latin typeface="Times New Roman" charset="0"/>
@@ -14471,7 +14437,7 @@
                           <a:ea typeface="Times New Roman" pitchFamily="34" charset="-122"/>
                           <a:cs typeface="Times New Roman" pitchFamily="34" charset="-120"/>
                         </a:rPr>
-                        <a:t>Χωρητικότητα</a:t>
+                        <a:t>Capacity</a:t>
                       </a:r>
                       <a:endParaRPr lang="en-US" sz="1300" dirty="0">
                         <a:latin typeface="Times New Roman" charset="0"/>
@@ -14515,7 +14481,7 @@
                           <a:ea typeface="Times New Roman" pitchFamily="34" charset="-122"/>
                           <a:cs typeface="Times New Roman" pitchFamily="34" charset="-120"/>
                         </a:rPr>
-                        <a:t>100% αξιοποιήσιμη</a:t>
+                        <a:t>100% χρησιμοποιήσιμη</a:t>
                       </a:r>
                       <a:endParaRPr lang="en-US" sz="1300" dirty="0">
                         <a:latin typeface="Times New Roman" charset="0"/>
@@ -14559,7 +14525,7 @@
                           <a:ea typeface="Times New Roman" pitchFamily="34" charset="-122"/>
                           <a:cs typeface="Times New Roman" pitchFamily="34" charset="-120"/>
                         </a:rPr>
-                        <a:t>Γρήγορη βαθμίδα → κρυφή μνήμη</a:t>
+                        <a:t>το γρήγορο tier γίνεται cache</a:t>
                       </a:r>
                       <a:endParaRPr lang="en-US" sz="1300" dirty="0">
                         <a:latin typeface="Times New Roman" charset="0"/>
@@ -14605,7 +14571,7 @@
                           <a:ea typeface="Times New Roman" pitchFamily="34" charset="-122"/>
                           <a:cs typeface="Times New Roman" pitchFamily="34" charset="-120"/>
                         </a:rPr>
-                        <a:t>Αστοχίες σύγκρουσης</a:t>
+                        <a:t>Conflict misses</a:t>
                       </a:r>
                       <a:endParaRPr lang="en-US" sz="1300" dirty="0">
                         <a:latin typeface="Times New Roman" charset="0"/>
@@ -14649,7 +14615,7 @@
                           <a:ea typeface="Times New Roman" pitchFamily="34" charset="-122"/>
                           <a:cs typeface="Times New Roman" pitchFamily="34" charset="-120"/>
                         </a:rPr>
-                        <a:t>Δεν υφίστανται</a:t>
+                        <a:t>Δεν υπάρχουν</a:t>
                       </a:r>
                       <a:endParaRPr lang="en-US" sz="1300" dirty="0">
                         <a:latin typeface="Times New Roman" charset="0"/>
@@ -14693,7 +14659,7 @@
                           <a:ea typeface="Times New Roman" pitchFamily="34" charset="-122"/>
                           <a:cs typeface="Times New Roman" pitchFamily="34" charset="-120"/>
                         </a:rPr>
-                        <a:t>Ναι — και μεταξύ ενοίκων</a:t>
+                        <a:t>Ναι — και ανάμεσα σε VMs</a:t>
                       </a:r>
                       <a:endParaRPr lang="en-US" sz="1300" dirty="0">
                         <a:latin typeface="Times New Roman" charset="0"/>
@@ -14739,7 +14705,7 @@
                           <a:ea typeface="Times New Roman" pitchFamily="34" charset="-122"/>
                           <a:cs typeface="Times New Roman" pitchFamily="34" charset="-120"/>
                         </a:rPr>
-                        <a:t>Νέο υλικό</a:t>
+                        <a:t>Νέο hardware</a:t>
                       </a:r>
                       <a:endParaRPr lang="en-US" sz="1300" dirty="0">
                         <a:latin typeface="Times New Roman" charset="0"/>
@@ -14972,7 +14938,7 @@
                 <a:ea typeface="Times New Roman" pitchFamily="34" charset="-122"/>
                 <a:cs typeface="Times New Roman" pitchFamily="34" charset="-120"/>
               </a:rPr>
-              <a:t>η κοκκομέτρηση γραμμής εξαλείφει τη σπατάλη και το σταθερό κόστος, αλλά αγοράζει αστοχίες σύγκρουσης, αποθήκευση ετικετών και απώλεια της γρήγορης χωρητικότητας ως διευθυνσιοδοτήσιμης μνήμης. Δεν είναι καθαρή νίκη — γι’ αυτό και το πεδίο δεν έχει συγκλίνει.</a:t>
+              <a:t>το line granularity κόβει το waste και το σταθερό κόστος, αλλά φέρνει conflict misses, tag storage, και χάνεις τη γρήγορη capacity σαν χρησιμοποιήσιμη μνήμη. Δεν είναι καθαρή νίκη, και γι’ αυτό δεν έχει κλείσει το θέμα.</a:t>
             </a:r>
             <a:endParaRPr lang="en-US" sz="1450" dirty="0"/>
           </a:p>

</xml_diff>